<commit_message>
Superscore carousel: keep Nurassyl's edits, add cover photo, NU rules and SAT dates slides (12 slides)
Co-Authored-By: Claude Opus 5.5 <noreply@anthropic.com>
Claude-Session: https://claude.ai/code/session_01EUKBNPzc7y2DXSfnei23HU
</commit_message>
<xml_diff>
--- a/social/pptx/sat-superscore.pptx
+++ b/social/pptx/sat-superscore.pptx
@@ -15,9 +15,11 @@
     <p:sldId id="263" r:id="rId9"/>
     <p:sldId id="264" r:id="rId10"/>
     <p:sldId id="265" r:id="rId11"/>
+    <p:sldId id="266" r:id="rId12"/>
+    <p:sldId id="267" r:id="rId13"/>
   </p:sldIdLst>
   <p:notesMasterIdLst>
-    <p:notesMasterId r:id="rId12"/>
+    <p:notesMasterId r:id="rId14"/>
   </p:notesMasterIdLst>
   <p:sldSz cx="6858000" cy="8572500"/>
   <p:notesSz cx="8572500" cy="6858000"/>
@@ -623,6 +625,182 @@
             <a:fld id="{F7021451-1387-4CA6-816F-3879F97B5CBC}" type="slidenum">
               <a:rPr lang="en-US"/>
               <a:t>10</a:t>
+            </a:fld>
+            <a:endParaRPr lang="en-US"/>
+          </a:p>
+        </p:txBody>
+      </p:sp>
+    </p:spTree>
+    <p:extLst>
+      <p:ext uri="{BB962C8B-B14F-4D97-AF65-F5344CB8AC3E}">
+        <p14:creationId xmlns:p14="http://schemas.microsoft.com/office/powerpoint/2010/main" val="1024086991"/>
+      </p:ext>
+    </p:extLst>
+  </p:cSld>
+  <p:clrMapOvr>
+    <a:masterClrMapping/>
+  </p:clrMapOvr>
+</p:notes>
+</file>
+
+<file path=ppt/notesSlides/notesSlide11.xml><?xml version="1.0" encoding="utf-8"?>
+<p:notes xmlns:a="http://schemas.openxmlformats.org/drawingml/2006/main" xmlns:r="http://schemas.openxmlformats.org/officeDocument/2006/relationships" xmlns:p="http://schemas.openxmlformats.org/presentationml/2006/main">
+  <p:cSld>
+    <p:spTree>
+      <p:nvGrpSpPr>
+        <p:cNvPr id="1" name=""/>
+        <p:cNvGrpSpPr/>
+        <p:nvPr/>
+      </p:nvGrpSpPr>
+      <p:grpSpPr>
+        <a:xfrm>
+          <a:off x="0" y="0"/>
+          <a:ext cx="0" cy="0"/>
+          <a:chOff x="0" y="0"/>
+          <a:chExt cx="0" cy="0"/>
+        </a:xfrm>
+      </p:grpSpPr>
+      <p:sp>
+        <p:nvSpPr>
+          <p:cNvPr id="2" name="Slide Image Placeholder 1"/>
+          <p:cNvSpPr>
+            <a:spLocks noGrp="1" noRot="1" noChangeAspect="1"/>
+          </p:cNvSpPr>
+          <p:nvPr>
+            <p:ph type="sldImg"/>
+          </p:nvPr>
+        </p:nvSpPr>
+        <p:spPr/>
+      </p:sp>
+      <p:sp>
+        <p:nvSpPr>
+          <p:cNvPr id="3" name="Notes Placeholder 2"/>
+          <p:cNvSpPr>
+            <a:spLocks noGrp="1"/>
+          </p:cNvSpPr>
+          <p:nvPr>
+            <p:ph type="body" idx="1"/>
+          </p:nvPr>
+        </p:nvSpPr>
+        <p:spPr/>
+        <p:txBody>
+          <a:bodyPr/>
+          <a:lstStyle/>
+          <a:p>
+            <a:r>
+              <a:rPr lang="en-US" dirty="0"/>
+              <a:t/>
+            </a:r>
+            <a:endParaRPr lang="en-US" dirty="0"/>
+          </a:p>
+        </p:txBody>
+      </p:sp>
+      <p:sp>
+        <p:nvSpPr>
+          <p:cNvPr id="4" name="Slide Number Placeholder 3"/>
+          <p:cNvSpPr>
+            <a:spLocks noGrp="1"/>
+          </p:cNvSpPr>
+          <p:nvPr>
+            <p:ph type="sldNum" sz="quarter" idx="10"/>
+          </p:nvPr>
+        </p:nvSpPr>
+        <p:spPr/>
+        <p:txBody>
+          <a:bodyPr/>
+          <a:lstStyle/>
+          <a:p>
+            <a:fld id="{F7021451-1387-4CA6-816F-3879F97B5CBC}" type="slidenum">
+              <a:rPr lang="en-US"/>
+              <a:t>11</a:t>
+            </a:fld>
+            <a:endParaRPr lang="en-US"/>
+          </a:p>
+        </p:txBody>
+      </p:sp>
+    </p:spTree>
+    <p:extLst>
+      <p:ext uri="{BB962C8B-B14F-4D97-AF65-F5344CB8AC3E}">
+        <p14:creationId xmlns:p14="http://schemas.microsoft.com/office/powerpoint/2010/main" val="1024086991"/>
+      </p:ext>
+    </p:extLst>
+  </p:cSld>
+  <p:clrMapOvr>
+    <a:masterClrMapping/>
+  </p:clrMapOvr>
+</p:notes>
+</file>
+
+<file path=ppt/notesSlides/notesSlide12.xml><?xml version="1.0" encoding="utf-8"?>
+<p:notes xmlns:a="http://schemas.openxmlformats.org/drawingml/2006/main" xmlns:r="http://schemas.openxmlformats.org/officeDocument/2006/relationships" xmlns:p="http://schemas.openxmlformats.org/presentationml/2006/main">
+  <p:cSld>
+    <p:spTree>
+      <p:nvGrpSpPr>
+        <p:cNvPr id="1" name=""/>
+        <p:cNvGrpSpPr/>
+        <p:nvPr/>
+      </p:nvGrpSpPr>
+      <p:grpSpPr>
+        <a:xfrm>
+          <a:off x="0" y="0"/>
+          <a:ext cx="0" cy="0"/>
+          <a:chOff x="0" y="0"/>
+          <a:chExt cx="0" cy="0"/>
+        </a:xfrm>
+      </p:grpSpPr>
+      <p:sp>
+        <p:nvSpPr>
+          <p:cNvPr id="2" name="Slide Image Placeholder 1"/>
+          <p:cNvSpPr>
+            <a:spLocks noGrp="1" noRot="1" noChangeAspect="1"/>
+          </p:cNvSpPr>
+          <p:nvPr>
+            <p:ph type="sldImg"/>
+          </p:nvPr>
+        </p:nvSpPr>
+        <p:spPr/>
+      </p:sp>
+      <p:sp>
+        <p:nvSpPr>
+          <p:cNvPr id="3" name="Notes Placeholder 2"/>
+          <p:cNvSpPr>
+            <a:spLocks noGrp="1"/>
+          </p:cNvSpPr>
+          <p:nvPr>
+            <p:ph type="body" idx="1"/>
+          </p:nvPr>
+        </p:nvSpPr>
+        <p:spPr/>
+        <p:txBody>
+          <a:bodyPr/>
+          <a:lstStyle/>
+          <a:p>
+            <a:r>
+              <a:rPr lang="en-US" dirty="0"/>
+              <a:t/>
+            </a:r>
+            <a:endParaRPr lang="en-US" dirty="0"/>
+          </a:p>
+        </p:txBody>
+      </p:sp>
+      <p:sp>
+        <p:nvSpPr>
+          <p:cNvPr id="4" name="Slide Number Placeholder 3"/>
+          <p:cNvSpPr>
+            <a:spLocks noGrp="1"/>
+          </p:cNvSpPr>
+          <p:nvPr>
+            <p:ph type="sldNum" sz="quarter" idx="10"/>
+          </p:nvPr>
+        </p:nvSpPr>
+        <p:spPr/>
+        <p:txBody>
+          <a:bodyPr/>
+          <a:lstStyle/>
+          <a:p>
+            <a:fld id="{F7021451-1387-4CA6-816F-3879F97B5CBC}" type="slidenum">
+              <a:rPr lang="en-US"/>
+              <a:t>12</a:t>
             </a:fld>
             <a:endParaRPr lang="en-US"/>
           </a:p>
@@ -1812,7 +1990,7 @@
                 <a:ea typeface="IBM Plex Mono" pitchFamily="34" charset="-122"/>
                 <a:cs typeface="IBM Plex Mono" pitchFamily="34" charset="-120"/>
               </a:rPr>
-              <a:t>01 / 10</a:t>
+              <a:t>01 / 12</a:t>
             </a:r>
             <a:endParaRPr lang="en-US" sz="1000" dirty="0"/>
           </a:p>
@@ -1826,27 +2004,27 @@
         </p:nvSpPr>
         <p:spPr>
           <a:xfrm>
-            <a:off x="457200" y="951409"/>
-            <a:ext cx="6300216" cy="1231900"/>
-          </a:xfrm>
-          <a:prstGeom prst="rect">
-            <a:avLst/>
-          </a:prstGeom>
-          <a:noFill/>
-          <a:ln/>
-        </p:spPr>
-        <p:txBody>
-          <a:bodyPr wrap="square" lIns="0" tIns="0" rIns="0" bIns="0" rtlCol="0" anchor="t"/>
-          <a:lstStyle/>
-          <a:p>
-            <a:pPr algn="l" indent="0" marL="0">
-              <a:lnSpc>
-                <a:spcPts val="4690"/>
-              </a:lnSpc>
-              <a:buNone/>
-            </a:pPr>
-            <a:r>
-              <a:rPr lang="en-US" sz="4600" b="1" spc="-160" kern="0" dirty="0">
+            <a:off x="457200" y="953591"/>
+            <a:ext cx="6300216" cy="1168400"/>
+          </a:xfrm>
+          <a:prstGeom prst="rect">
+            <a:avLst/>
+          </a:prstGeom>
+          <a:noFill/>
+          <a:ln/>
+        </p:spPr>
+        <p:txBody>
+          <a:bodyPr wrap="square" lIns="0" tIns="0" rIns="0" bIns="0" rtlCol="0" anchor="t"/>
+          <a:lstStyle/>
+          <a:p>
+            <a:pPr algn="l" indent="0" marL="0">
+              <a:lnSpc>
+                <a:spcPts val="4280"/>
+              </a:lnSpc>
+              <a:buNone/>
+            </a:pPr>
+            <a:r>
+              <a:rPr lang="en-US" sz="4200" b="1" spc="-150" kern="0" dirty="0">
                 <a:solidFill>
                   <a:srgbClr val="0A0A0A"/>
                 </a:solidFill>
@@ -1858,7 +2036,7 @@
             </a:r>
             <a:pPr algn="l" indent="0" marL="0">
               <a:lnSpc>
-                <a:spcPts val="4690"/>
+                <a:spcPts val="4280"/>
               </a:lnSpc>
               <a:buNone/>
             </a:pPr>
@@ -1873,7 +2051,7 @@
               </a:rPr>
               <a:t>за один раз</a:t>
             </a:r>
-            <a:endParaRPr lang="en-US" sz="4600" dirty="0"/>
+            <a:endParaRPr lang="en-US" sz="4200" dirty="0"/>
           </a:p>
         </p:txBody>
       </p:sp>
@@ -1885,27 +2063,27 @@
         </p:nvSpPr>
         <p:spPr>
           <a:xfrm>
-            <a:off x="457696" y="2309217"/>
-            <a:ext cx="5889625" cy="533400"/>
-          </a:xfrm>
-          <a:prstGeom prst="rect">
-            <a:avLst/>
-          </a:prstGeom>
-          <a:noFill/>
-          <a:ln/>
-        </p:spPr>
-        <p:txBody>
-          <a:bodyPr wrap="square" lIns="0" tIns="0" rIns="0" bIns="0" rtlCol="0" anchor="t"/>
-          <a:lstStyle/>
-          <a:p>
-            <a:pPr algn="l" indent="0" marL="0">
-              <a:lnSpc>
-                <a:spcPts val="2100"/>
-              </a:lnSpc>
-              <a:buNone/>
-            </a:pPr>
-            <a:r>
-              <a:rPr lang="en-US" sz="1500" dirty="0">
+            <a:off x="455811" y="2251273"/>
+            <a:ext cx="5001133" cy="495300"/>
+          </a:xfrm>
+          <a:prstGeom prst="rect">
+            <a:avLst/>
+          </a:prstGeom>
+          <a:noFill/>
+          <a:ln/>
+        </p:spPr>
+        <p:txBody>
+          <a:bodyPr wrap="square" lIns="0" tIns="0" rIns="0" bIns="0" rtlCol="0" anchor="t"/>
+          <a:lstStyle/>
+          <a:p>
+            <a:pPr algn="l" indent="0" marL="0">
+              <a:lnSpc>
+                <a:spcPts val="1960"/>
+              </a:lnSpc>
+              <a:buNone/>
+            </a:pPr>
+            <a:r>
+              <a:rPr lang="en-US" sz="1400" dirty="0">
                 <a:solidFill>
                   <a:srgbClr val="2B2A27"/>
                 </a:solidFill>
@@ -1915,7 +2093,7 @@
               </a:rPr>
               <a:t>Но в заявке у меня стоит 1560. Рассказываю, как это работает и где это не сработает.</a:t>
             </a:r>
-            <a:endParaRPr lang="en-US" sz="1500" dirty="0"/>
+            <a:endParaRPr lang="en-US" sz="1400" dirty="0"/>
           </a:p>
         </p:txBody>
       </p:sp>
@@ -1927,8 +2105,8 @@
         </p:nvSpPr>
         <p:spPr>
           <a:xfrm>
-            <a:off x="338328" y="3556000"/>
-            <a:ext cx="6181344" cy="1885950"/>
+            <a:off x="2590800" y="2794000"/>
+            <a:ext cx="3962400" cy="1314450"/>
           </a:xfrm>
           <a:prstGeom prst="rect">
             <a:avLst/>
@@ -1942,12 +2120,12 @@
           <a:p>
             <a:pPr algn="ctr" indent="0" marL="0">
               <a:lnSpc>
-                <a:spcPts val="14850"/>
-              </a:lnSpc>
-              <a:buNone/>
-            </a:pPr>
-            <a:r>
-              <a:rPr lang="en-US" sz="16500" i="1" spc="-660" kern="0" dirty="0">
+                <a:spcPts val="10350"/>
+              </a:lnSpc>
+              <a:buNone/>
+            </a:pPr>
+            <a:r>
+              <a:rPr lang="en-US" sz="11500" i="1" spc="-460" kern="0" dirty="0">
                 <a:solidFill>
                   <a:srgbClr val="0A0A0A"/>
                 </a:solidFill>
@@ -1957,119 +2135,13 @@
               </a:rPr>
               <a:t>1560</a:t>
             </a:r>
-            <a:endParaRPr lang="en-US" sz="16500" dirty="0"/>
-          </a:p>
-        </p:txBody>
-      </p:sp>
-      <p:sp>
-        <p:nvSpPr>
-          <p:cNvPr id="9" name="text-8"/>
-          <p:cNvSpPr txBox="1"/>
-          <p:nvPr/>
-        </p:nvSpPr>
-        <p:spPr>
-          <a:xfrm>
-            <a:off x="457845" y="7969250"/>
-            <a:ext cx="895223" cy="171450"/>
-          </a:xfrm>
-          <a:prstGeom prst="rect">
-            <a:avLst/>
-          </a:prstGeom>
-          <a:noFill/>
-          <a:ln/>
-        </p:spPr>
-        <p:txBody>
-          <a:bodyPr wrap="square" lIns="0" tIns="0" rIns="0" bIns="0" rtlCol="0" anchor="t"/>
-          <a:lstStyle/>
-          <a:p>
-            <a:pPr algn="l" indent="0" marL="0">
-              <a:lnSpc>
-                <a:spcPts val="1200"/>
-              </a:lnSpc>
-              <a:buNone/>
-            </a:pPr>
-            <a:r>
-              <a:rPr lang="en-US" sz="1000" spc="140" kern="0" dirty="0">
-                <a:solidFill>
-                  <a:srgbClr val="0A0A0A"/>
-                </a:solidFill>
-                <a:latin typeface="IBM Plex Mono" pitchFamily="34" charset="0"/>
-                <a:ea typeface="IBM Plex Mono" pitchFamily="34" charset="-122"/>
-                <a:cs typeface="IBM Plex Mono" pitchFamily="34" charset="-120"/>
-              </a:rPr>
-              <a:t>@NURZYCOM</a:t>
-            </a:r>
-            <a:endParaRPr lang="en-US" sz="1000" dirty="0"/>
-          </a:p>
-        </p:txBody>
-      </p:sp>
-      <p:sp>
-        <p:nvSpPr>
-          <p:cNvPr id="10" name="shape-9"/>
-          <p:cNvSpPr/>
-          <p:nvPr/>
-        </p:nvSpPr>
-        <p:spPr>
-          <a:xfrm>
-            <a:off x="5340945" y="7893050"/>
-            <a:ext cx="1060450" cy="323850"/>
-          </a:xfrm>
-          <a:prstGeom prst="roundRect">
-            <a:avLst>
-              <a:gd name="adj" fmla="val 50000"/>
-            </a:avLst>
-          </a:prstGeom>
-          <a:solidFill>
-            <a:srgbClr val="0A0A0A"/>
-          </a:solidFill>
-          <a:ln/>
-        </p:spPr>
-      </p:sp>
-      <p:sp>
-        <p:nvSpPr>
-          <p:cNvPr id="11" name="text-10"/>
-          <p:cNvSpPr txBox="1"/>
-          <p:nvPr/>
-        </p:nvSpPr>
-        <p:spPr>
-          <a:xfrm>
-            <a:off x="5480645" y="7969250"/>
-            <a:ext cx="599059" cy="171450"/>
-          </a:xfrm>
-          <a:prstGeom prst="rect">
-            <a:avLst/>
-          </a:prstGeom>
-          <a:noFill/>
-          <a:ln/>
-        </p:spPr>
-        <p:txBody>
-          <a:bodyPr wrap="square" lIns="0" tIns="0" rIns="0" bIns="0" rtlCol="0" anchor="t"/>
-          <a:lstStyle/>
-          <a:p>
-            <a:pPr algn="l" indent="0" marL="0">
-              <a:lnSpc>
-                <a:spcPts val="1200"/>
-              </a:lnSpc>
-              <a:buNone/>
-            </a:pPr>
-            <a:r>
-              <a:rPr lang="en-US" sz="1000" spc="140" kern="0" dirty="0">
-                <a:solidFill>
-                  <a:srgbClr val="FAF8F3"/>
-                </a:solidFill>
-                <a:latin typeface="IBM Plex Mono" pitchFamily="34" charset="0"/>
-                <a:ea typeface="IBM Plex Mono" pitchFamily="34" charset="-122"/>
-                <a:cs typeface="IBM Plex Mono" pitchFamily="34" charset="-120"/>
-              </a:rPr>
-              <a:t>ЛИСТАЙ</a:t>
-            </a:r>
-            <a:endParaRPr lang="en-US" sz="1000" dirty="0"/>
+            <a:endParaRPr lang="en-US" sz="11500" dirty="0"/>
           </a:p>
         </p:txBody>
       </p:sp>
       <p:pic>
         <p:nvPicPr>
-          <p:cNvPr id="12" name="svg-11" descr="preencoded.png">    </p:cNvPr>
+          <p:cNvPr id="9" name="img-8" descr="preencoded.png">    </p:cNvPr>
           <p:cNvPicPr>
             <a:picLocks noChangeAspect="1"/>
           </p:cNvPicPr>
@@ -2083,8 +2155,8 @@
         </p:blipFill>
         <p:spPr>
           <a:xfrm>
-            <a:off x="6121400" y="7985125"/>
-            <a:ext cx="139700" cy="139700"/>
+            <a:off x="2730500" y="3830141"/>
+            <a:ext cx="3556000" cy="4743450"/>
           </a:xfrm>
           <a:prstGeom prst="rect">
             <a:avLst/>
@@ -2093,13 +2165,84 @@
       </p:pic>
       <p:sp>
         <p:nvSpPr>
-          <p:cNvPr id="13" name="shape-12"/>
+          <p:cNvPr id="10" name="shape-9"/>
           <p:cNvSpPr/>
           <p:nvPr/>
         </p:nvSpPr>
         <p:spPr>
+          <a:xfrm rot="-240000">
+            <a:off x="380554" y="3302000"/>
+            <a:ext cx="2381250" cy="425450"/>
+          </a:xfrm>
+          <a:prstGeom prst="roundRect">
+            <a:avLst>
+              <a:gd name="adj" fmla="val 50000"/>
+            </a:avLst>
+          </a:prstGeom>
+          <a:solidFill>
+            <a:srgbClr val="0A0A0A"/>
+          </a:solidFill>
+          <a:ln/>
+          <a:effectLst>
+            <a:outerShdw sx="100000" sy="100000" kx="0" ky="0" algn="bl" rotWithShape="0" blurRad="177800" dist="76200" dir="5400000">
+              <a:srgbClr val="000000">
+                <a:alpha val="22000"/>
+              </a:srgbClr>
+            </a:outerShdw>
+          </a:effectLst>
+        </p:spPr>
+      </p:sp>
+      <p:sp>
+        <p:nvSpPr>
+          <p:cNvPr id="11" name="text-10"/>
+          <p:cNvSpPr txBox="1"/>
+          <p:nvPr/>
+        </p:nvSpPr>
+        <p:spPr>
+          <a:xfrm rot="-240000">
+            <a:off x="532954" y="3390900"/>
+            <a:ext cx="2201037" cy="247650"/>
+          </a:xfrm>
+          <a:prstGeom prst="rect">
+            <a:avLst/>
+          </a:prstGeom>
+          <a:noFill/>
+          <a:ln/>
+        </p:spPr>
+        <p:txBody>
+          <a:bodyPr wrap="square" lIns="0" tIns="0" rIns="0" bIns="0" rtlCol="0" anchor="t"/>
+          <a:lstStyle/>
+          <a:p>
+            <a:pPr algn="l" indent="0" marL="0">
+              <a:lnSpc>
+                <a:spcPts val="1800"/>
+              </a:lnSpc>
+              <a:buNone/>
+            </a:pPr>
+            <a:r>
+              <a:rPr lang="en-US" sz="1500" b="1" spc="-10" kern="0" dirty="0">
+                <a:solidFill>
+                  <a:srgbClr val="FAF8F3"/>
+                </a:solidFill>
+                <a:latin typeface="Geist" pitchFamily="34" charset="0"/>
+                <a:ea typeface="Geist" pitchFamily="34" charset="-122"/>
+                <a:cs typeface="Geist" pitchFamily="34" charset="-120"/>
+              </a:rPr>
+              <a:t>ни разу за одну сдачу</a:t>
+            </a:r>
+            <a:endParaRPr lang="en-US" sz="1500" dirty="0"/>
+          </a:p>
+        </p:txBody>
+      </p:sp>
+      <p:sp>
+        <p:nvSpPr>
+          <p:cNvPr id="12" name="shape-11"/>
+          <p:cNvSpPr/>
+          <p:nvPr/>
+        </p:nvSpPr>
+        <p:spPr>
           <a:xfrm rot="-300000">
-            <a:off x="699641" y="5842000"/>
+            <a:off x="509141" y="4889500"/>
             <a:ext cx="1270000" cy="450850"/>
           </a:xfrm>
           <a:prstGeom prst="roundRect">
@@ -2127,13 +2270,13 @@
       </p:sp>
       <p:sp>
         <p:nvSpPr>
-          <p:cNvPr id="14" name="text-13"/>
+          <p:cNvPr id="13" name="text-12"/>
           <p:cNvSpPr txBox="1"/>
           <p:nvPr/>
         </p:nvSpPr>
         <p:spPr>
           <a:xfrm rot="-300000">
-            <a:off x="852041" y="5930900"/>
+            <a:off x="661541" y="4978400"/>
             <a:ext cx="1023112" cy="273050"/>
           </a:xfrm>
           <a:prstGeom prst="rect">
@@ -2169,13 +2312,13 @@
       </p:sp>
       <p:sp>
         <p:nvSpPr>
-          <p:cNvPr id="15" name="shape-14"/>
+          <p:cNvPr id="14" name="shape-13"/>
           <p:cNvSpPr/>
           <p:nvPr/>
         </p:nvSpPr>
         <p:spPr>
           <a:xfrm rot="240000">
-            <a:off x="4450407" y="6032500"/>
+            <a:off x="762942" y="5461000"/>
             <a:ext cx="1708150" cy="450850"/>
           </a:xfrm>
           <a:prstGeom prst="roundRect">
@@ -2203,13 +2346,13 @@
       </p:sp>
       <p:sp>
         <p:nvSpPr>
-          <p:cNvPr id="16" name="text-15"/>
+          <p:cNvPr id="15" name="text-14"/>
           <p:cNvSpPr txBox="1"/>
           <p:nvPr/>
         </p:nvSpPr>
         <p:spPr>
           <a:xfrm rot="240000">
-            <a:off x="4602807" y="6121400"/>
+            <a:off x="915342" y="5549900"/>
             <a:ext cx="1487551" cy="273050"/>
           </a:xfrm>
           <a:prstGeom prst="rect">
@@ -2245,14 +2388,98 @@
       </p:sp>
       <p:sp>
         <p:nvSpPr>
-          <p:cNvPr id="17" name="shape-16"/>
+          <p:cNvPr id="16" name="text-15"/>
+          <p:cNvSpPr txBox="1"/>
+          <p:nvPr/>
+        </p:nvSpPr>
+        <p:spPr>
+          <a:xfrm>
+            <a:off x="457200" y="6476305"/>
+            <a:ext cx="2288540" cy="533400"/>
+          </a:xfrm>
+          <a:prstGeom prst="rect">
+            <a:avLst/>
+          </a:prstGeom>
+          <a:noFill/>
+          <a:ln/>
+        </p:spPr>
+        <p:txBody>
+          <a:bodyPr wrap="square" lIns="0" tIns="0" rIns="0" bIns="0" rtlCol="0" anchor="t"/>
+          <a:lstStyle/>
+          <a:p>
+            <a:pPr algn="l" indent="0" marL="0">
+              <a:lnSpc>
+                <a:spcPts val="2070"/>
+              </a:lnSpc>
+              <a:buNone/>
+            </a:pPr>
+            <a:r>
+              <a:rPr lang="en-US" sz="1800" i="1" dirty="0">
+                <a:solidFill>
+                  <a:srgbClr val="0A0A0A"/>
+                </a:solidFill>
+                <a:latin typeface="Noto Serif Display Light" pitchFamily="34" charset="0"/>
+                <a:ea typeface="Noto Serif Display Light" pitchFamily="34" charset="-122"/>
+                <a:cs typeface="Noto Serif Display Light" pitchFamily="34" charset="-120"/>
+              </a:rPr>
+              <a:t>начнём с моих двух попыток</a:t>
+            </a:r>
+            <a:endParaRPr lang="en-US" sz="1800" dirty="0"/>
+          </a:p>
+        </p:txBody>
+      </p:sp>
+      <p:sp>
+        <p:nvSpPr>
+          <p:cNvPr id="17" name="text-16"/>
+          <p:cNvSpPr txBox="1"/>
+          <p:nvPr/>
+        </p:nvSpPr>
+        <p:spPr>
+          <a:xfrm>
+            <a:off x="457845" y="7969250"/>
+            <a:ext cx="895223" cy="171450"/>
+          </a:xfrm>
+          <a:prstGeom prst="rect">
+            <a:avLst/>
+          </a:prstGeom>
+          <a:noFill/>
+          <a:ln/>
+        </p:spPr>
+        <p:txBody>
+          <a:bodyPr wrap="square" lIns="0" tIns="0" rIns="0" bIns="0" rtlCol="0" anchor="t"/>
+          <a:lstStyle/>
+          <a:p>
+            <a:pPr algn="l" indent="0" marL="0">
+              <a:lnSpc>
+                <a:spcPts val="1200"/>
+              </a:lnSpc>
+              <a:buNone/>
+            </a:pPr>
+            <a:r>
+              <a:rPr lang="en-US" sz="1000" spc="140" kern="0" dirty="0">
+                <a:solidFill>
+                  <a:srgbClr val="0A0A0A"/>
+                </a:solidFill>
+                <a:latin typeface="IBM Plex Mono" pitchFamily="34" charset="0"/>
+                <a:ea typeface="IBM Plex Mono" pitchFamily="34" charset="-122"/>
+                <a:cs typeface="IBM Plex Mono" pitchFamily="34" charset="-120"/>
+              </a:rPr>
+              <a:t>@NURZYCOM</a:t>
+            </a:r>
+            <a:endParaRPr lang="en-US" sz="1000" dirty="0"/>
+          </a:p>
+        </p:txBody>
+      </p:sp>
+      <p:sp>
+        <p:nvSpPr>
+          <p:cNvPr id="18" name="shape-17"/>
           <p:cNvSpPr/>
           <p:nvPr/>
         </p:nvSpPr>
         <p:spPr>
-          <a:xfrm rot="480000">
-            <a:off x="3969196" y="3175000"/>
-            <a:ext cx="2381250" cy="425450"/>
+          <a:xfrm>
+            <a:off x="5340945" y="7893050"/>
+            <a:ext cx="1060450" cy="323850"/>
           </a:xfrm>
           <a:prstGeom prst="roundRect">
             <a:avLst>
@@ -2263,99 +2490,74 @@
             <a:srgbClr val="0A0A0A"/>
           </a:solidFill>
           <a:ln/>
-          <a:effectLst>
-            <a:outerShdw sx="100000" sy="100000" kx="0" ky="0" algn="bl" rotWithShape="0" blurRad="177800" dist="76200" dir="5400000">
-              <a:srgbClr val="000000">
-                <a:alpha val="22000"/>
-              </a:srgbClr>
-            </a:outerShdw>
-          </a:effectLst>
-        </p:spPr>
-      </p:sp>
-      <p:sp>
-        <p:nvSpPr>
-          <p:cNvPr id="18" name="text-17"/>
-          <p:cNvSpPr txBox="1"/>
-          <p:nvPr/>
-        </p:nvSpPr>
-        <p:spPr>
-          <a:xfrm rot="480000">
-            <a:off x="4121596" y="3263900"/>
-            <a:ext cx="2201037" cy="247650"/>
-          </a:xfrm>
-          <a:prstGeom prst="rect">
-            <a:avLst/>
-          </a:prstGeom>
-          <a:noFill/>
-          <a:ln/>
-        </p:spPr>
-        <p:txBody>
-          <a:bodyPr wrap="square" lIns="0" tIns="0" rIns="0" bIns="0" rtlCol="0" anchor="t"/>
-          <a:lstStyle/>
-          <a:p>
-            <a:pPr algn="l" indent="0" marL="0">
-              <a:lnSpc>
-                <a:spcPts val="1800"/>
-              </a:lnSpc>
-              <a:buNone/>
-            </a:pPr>
-            <a:r>
-              <a:rPr lang="en-US" sz="1500" b="1" spc="-10" kern="0" dirty="0">
+        </p:spPr>
+      </p:sp>
+      <p:sp>
+        <p:nvSpPr>
+          <p:cNvPr id="19" name="text-18"/>
+          <p:cNvSpPr txBox="1"/>
+          <p:nvPr/>
+        </p:nvSpPr>
+        <p:spPr>
+          <a:xfrm>
+            <a:off x="5480645" y="7969250"/>
+            <a:ext cx="599059" cy="171450"/>
+          </a:xfrm>
+          <a:prstGeom prst="rect">
+            <a:avLst/>
+          </a:prstGeom>
+          <a:noFill/>
+          <a:ln/>
+        </p:spPr>
+        <p:txBody>
+          <a:bodyPr wrap="square" lIns="0" tIns="0" rIns="0" bIns="0" rtlCol="0" anchor="t"/>
+          <a:lstStyle/>
+          <a:p>
+            <a:pPr algn="l" indent="0" marL="0">
+              <a:lnSpc>
+                <a:spcPts val="1200"/>
+              </a:lnSpc>
+              <a:buNone/>
+            </a:pPr>
+            <a:r>
+              <a:rPr lang="en-US" sz="1000" spc="140" kern="0" dirty="0">
                 <a:solidFill>
                   <a:srgbClr val="FAF8F3"/>
                 </a:solidFill>
-                <a:latin typeface="Geist" pitchFamily="34" charset="0"/>
-                <a:ea typeface="Geist" pitchFamily="34" charset="-122"/>
-                <a:cs typeface="Geist" pitchFamily="34" charset="-120"/>
-              </a:rPr>
-              <a:t>ни разу за одну сдачу</a:t>
-            </a:r>
-            <a:endParaRPr lang="en-US" sz="1500" dirty="0"/>
-          </a:p>
-        </p:txBody>
-      </p:sp>
-      <p:sp>
-        <p:nvSpPr>
-          <p:cNvPr id="19" name="text-18"/>
-          <p:cNvSpPr txBox="1"/>
-          <p:nvPr/>
-        </p:nvSpPr>
-        <p:spPr>
-          <a:xfrm>
-            <a:off x="457200" y="7303740"/>
-            <a:ext cx="6300216" cy="266700"/>
-          </a:xfrm>
-          <a:prstGeom prst="rect">
-            <a:avLst/>
-          </a:prstGeom>
-          <a:noFill/>
-          <a:ln/>
-        </p:spPr>
-        <p:txBody>
-          <a:bodyPr wrap="square" lIns="0" tIns="0" rIns="0" bIns="0" rtlCol="0" anchor="t"/>
-          <a:lstStyle/>
-          <a:p>
-            <a:pPr algn="l" indent="0" marL="0">
-              <a:lnSpc>
-                <a:spcPts val="2070"/>
-              </a:lnSpc>
-              <a:buNone/>
-            </a:pPr>
-            <a:r>
-              <a:rPr lang="en-US" sz="1800" i="1" dirty="0">
-                <a:solidFill>
-                  <a:srgbClr val="0A0A0A"/>
-                </a:solidFill>
-                <a:latin typeface="Noto Serif Display Light" pitchFamily="34" charset="0"/>
-                <a:ea typeface="Noto Serif Display Light" pitchFamily="34" charset="-122"/>
-                <a:cs typeface="Noto Serif Display Light" pitchFamily="34" charset="-120"/>
-              </a:rPr>
-              <a:t>начнём с моих двух попыток</a:t>
-            </a:r>
-            <a:endParaRPr lang="en-US" sz="1800" dirty="0"/>
-          </a:p>
-        </p:txBody>
-      </p:sp>
+                <a:latin typeface="IBM Plex Mono" pitchFamily="34" charset="0"/>
+                <a:ea typeface="IBM Plex Mono" pitchFamily="34" charset="-122"/>
+                <a:cs typeface="IBM Plex Mono" pitchFamily="34" charset="-120"/>
+              </a:rPr>
+              <a:t>ЛИСТАЙ</a:t>
+            </a:r>
+            <a:endParaRPr lang="en-US" sz="1000" dirty="0"/>
+          </a:p>
+        </p:txBody>
+      </p:sp>
+      <p:pic>
+        <p:nvPicPr>
+          <p:cNvPr id="20" name="svg-19" descr="preencoded.png">    </p:cNvPr>
+          <p:cNvPicPr>
+            <a:picLocks noChangeAspect="1"/>
+          </p:cNvPicPr>
+          <p:nvPr/>
+        </p:nvPicPr>
+        <p:blipFill>
+          <a:blip r:embed="rId4"/>
+          <a:stretch>
+            <a:fillRect/>
+          </a:stretch>
+        </p:blipFill>
+        <p:spPr>
+          <a:xfrm>
+            <a:off x="6121400" y="7985125"/>
+            <a:ext cx="139700" cy="139700"/>
+          </a:xfrm>
+          <a:prstGeom prst="rect">
+            <a:avLst/>
+          </a:prstGeom>
+        </p:spPr>
+      </p:pic>
     </p:spTree>
   </p:cSld>
   <p:clrMapOvr>
@@ -2403,8 +2605,8 @@
         </p:nvSpPr>
         <p:spPr>
           <a:xfrm>
-            <a:off x="457200" y="406400"/>
-            <a:ext cx="1397000" cy="323850"/>
+            <a:off x="458490" y="406400"/>
+            <a:ext cx="2146300" cy="323850"/>
           </a:xfrm>
           <a:prstGeom prst="roundRect">
             <a:avLst>
@@ -2454,8 +2656,8 @@
         </p:nvSpPr>
         <p:spPr>
           <a:xfrm>
-            <a:off x="787400" y="482600"/>
-            <a:ext cx="996188" cy="171450"/>
+            <a:off x="788690" y="482600"/>
+            <a:ext cx="1790446" cy="171450"/>
           </a:xfrm>
           <a:prstGeom prst="rect">
             <a:avLst/>
@@ -2482,7 +2684,7 @@
                 <a:ea typeface="IBM Plex Mono" pitchFamily="34" charset="-122"/>
                 <a:cs typeface="IBM Plex Mono" pitchFamily="34" charset="-120"/>
               </a:rPr>
-              <a:t>SAT · ПЛАН</a:t>
+              <a:t>SAT · SCORE CHOICE</a:t>
             </a:r>
             <a:endParaRPr lang="en-US" sz="1000" dirty="0"/>
           </a:p>
@@ -2524,7 +2726,7 @@
                 <a:ea typeface="IBM Plex Mono" pitchFamily="34" charset="-122"/>
                 <a:cs typeface="IBM Plex Mono" pitchFamily="34" charset="-120"/>
               </a:rPr>
-              <a:t>10 / 10</a:t>
+              <a:t>10 / 12</a:t>
             </a:r>
             <a:endParaRPr lang="en-US" sz="1000" dirty="0"/>
           </a:p>
@@ -2538,8 +2740,8 @@
         </p:nvSpPr>
         <p:spPr>
           <a:xfrm>
-            <a:off x="457200" y="951458"/>
-            <a:ext cx="6300216" cy="628650"/>
+            <a:off x="457200" y="953591"/>
+            <a:ext cx="6300216" cy="1250950"/>
           </a:xfrm>
           <a:prstGeom prst="rect">
             <a:avLst/>
@@ -2566,7 +2768,7 @@
                 <a:ea typeface="Geist" pitchFamily="34" charset="-122"/>
                 <a:cs typeface="Geist" pitchFamily="34" charset="-120"/>
               </a:rPr>
-              <a:t>План на </a:t>
+              <a:t>Ты выбираешь, </a:t>
             </a:r>
             <a:pPr algn="l" indent="0" marL="0">
               <a:lnSpc>
@@ -2583,7 +2785,7 @@
                 <a:ea typeface="Noto Serif Display Light" pitchFamily="34" charset="-122"/>
                 <a:cs typeface="Noto Serif Display Light" pitchFamily="34" charset="-120"/>
               </a:rPr>
-              <a:t>две сдачи</a:t>
+              <a:t>вуз считает</a:t>
             </a:r>
             <a:endParaRPr lang="en-US" sz="4200" dirty="0"/>
           </a:p>
@@ -2596,153 +2798,13 @@
           <p:nvPr/>
         </p:nvSpPr>
         <p:spPr>
-          <a:xfrm rot="-60000">
-            <a:off x="457200" y="2032050"/>
-            <a:ext cx="5943600" cy="793750"/>
+          <a:xfrm rot="-84000">
+            <a:off x="457200" y="2412405"/>
+            <a:ext cx="2901950" cy="1752600"/>
           </a:xfrm>
           <a:prstGeom prst="roundRect">
             <a:avLst>
-              <a:gd name="adj" fmla="val 22400"/>
-            </a:avLst>
-          </a:prstGeom>
-          <a:solidFill>
-            <a:srgbClr val="0A0A0A"/>
-          </a:solidFill>
-          <a:ln/>
-        </p:spPr>
-      </p:sp>
-      <p:sp>
-        <p:nvSpPr>
-          <p:cNvPr id="8" name="text-7"/>
-          <p:cNvSpPr txBox="1"/>
-          <p:nvPr/>
-        </p:nvSpPr>
-        <p:spPr>
-          <a:xfrm rot="-60000">
-            <a:off x="670329" y="2197124"/>
-            <a:ext cx="5842508" cy="146050"/>
-          </a:xfrm>
-          <a:prstGeom prst="rect">
-            <a:avLst/>
-          </a:prstGeom>
-          <a:noFill/>
-          <a:ln/>
-        </p:spPr>
-        <p:txBody>
-          <a:bodyPr wrap="square" lIns="0" tIns="0" rIns="0" bIns="0" rtlCol="0" anchor="t"/>
-          <a:lstStyle/>
-          <a:p>
-            <a:pPr algn="l" indent="0" marL="0">
-              <a:lnSpc>
-                <a:spcPts val="1080"/>
-              </a:lnSpc>
-              <a:buNone/>
-            </a:pPr>
-            <a:r>
-              <a:rPr lang="en-US" sz="900" spc="140" kern="0" dirty="0">
-                <a:solidFill>
-                  <a:srgbClr val="FAF8F3"/>
-                </a:solidFill>
-                <a:latin typeface="IBM Plex Mono" pitchFamily="34" charset="0"/>
-                <a:ea typeface="IBM Plex Mono" pitchFamily="34" charset="-122"/>
-                <a:cs typeface="IBM Plex Mono" pitchFamily="34" charset="-120"/>
-              </a:rPr>
-              <a:t>1</a:t>
-            </a:r>
-            <a:endParaRPr lang="en-US" sz="900" dirty="0"/>
-          </a:p>
-        </p:txBody>
-      </p:sp>
-      <p:sp>
-        <p:nvSpPr>
-          <p:cNvPr id="9" name="text-8"/>
-          <p:cNvSpPr txBox="1"/>
-          <p:nvPr/>
-        </p:nvSpPr>
-        <p:spPr>
-          <a:xfrm rot="-60000">
-            <a:off x="674929" y="2406684"/>
-            <a:ext cx="5842508" cy="254000"/>
-          </a:xfrm>
-          <a:prstGeom prst="rect">
-            <a:avLst/>
-          </a:prstGeom>
-          <a:noFill/>
-          <a:ln/>
-        </p:spPr>
-        <p:txBody>
-          <a:bodyPr wrap="square" lIns="0" tIns="0" rIns="0" bIns="0" rtlCol="0" anchor="t"/>
-          <a:lstStyle/>
-          <a:p>
-            <a:pPr algn="l" indent="0" marL="0">
-              <a:lnSpc>
-                <a:spcPts val="2000"/>
-              </a:lnSpc>
-              <a:buNone/>
-            </a:pPr>
-            <a:r>
-              <a:rPr lang="en-US" sz="1450" dirty="0">
-                <a:solidFill>
-                  <a:srgbClr val="FAF8F3"/>
-                </a:solidFill>
-                <a:latin typeface="Geist" pitchFamily="34" charset="0"/>
-                <a:ea typeface="Geist" pitchFamily="34" charset="-122"/>
-                <a:cs typeface="Geist" pitchFamily="34" charset="-120"/>
-              </a:rPr>
-              <a:t>Нужен высокий балл? Закладывай </a:t>
-            </a:r>
-            <a:pPr algn="l" indent="0" marL="0">
-              <a:lnSpc>
-                <a:spcPts val="2000"/>
-              </a:lnSpc>
-              <a:buNone/>
-            </a:pPr>
-            <a:r>
-              <a:rPr lang="en-US" sz="1450" b="1" dirty="0">
-                <a:solidFill>
-                  <a:srgbClr val="FAF8F3"/>
-                </a:solidFill>
-                <a:latin typeface="Geist" pitchFamily="34" charset="0"/>
-                <a:ea typeface="Geist" pitchFamily="34" charset="-122"/>
-                <a:cs typeface="Geist" pitchFamily="34" charset="-120"/>
-              </a:rPr>
-              <a:t>две попытки</a:t>
-            </a:r>
-            <a:pPr algn="l" indent="0" marL="0">
-              <a:lnSpc>
-                <a:spcPts val="2000"/>
-              </a:lnSpc>
-              <a:buNone/>
-            </a:pPr>
-            <a:r>
-              <a:rPr lang="en-US" sz="1450" dirty="0">
-                <a:solidFill>
-                  <a:srgbClr val="FAF8F3"/>
-                </a:solidFill>
-                <a:latin typeface="Geist" pitchFamily="34" charset="0"/>
-                <a:ea typeface="Geist" pitchFamily="34" charset="-122"/>
-                <a:cs typeface="Geist" pitchFamily="34" charset="-120"/>
-              </a:rPr>
-              <a:t>.</a:t>
-            </a:r>
-            <a:endParaRPr lang="en-US" sz="1450" dirty="0"/>
-          </a:p>
-        </p:txBody>
-      </p:sp>
-      <p:sp>
-        <p:nvSpPr>
-          <p:cNvPr id="10" name="shape-9"/>
-          <p:cNvSpPr/>
-          <p:nvPr/>
-        </p:nvSpPr>
-        <p:spPr>
-          <a:xfrm rot="60000">
-            <a:off x="457200" y="2927548"/>
-            <a:ext cx="5943600" cy="1047750"/>
-          </a:xfrm>
-          <a:prstGeom prst="roundRect">
-            <a:avLst>
-              <a:gd name="adj" fmla="val 16970"/>
+              <a:gd name="adj" fmla="val 9420"/>
             </a:avLst>
           </a:prstGeom>
           <a:solidFill>
@@ -2760,14 +2822,14 @@
       </p:sp>
       <p:sp>
         <p:nvSpPr>
-          <p:cNvPr id="11" name="text-10"/>
-          <p:cNvSpPr txBox="1"/>
-          <p:nvPr/>
-        </p:nvSpPr>
-        <p:spPr>
-          <a:xfrm rot="60000">
-            <a:off x="678089" y="3092593"/>
-            <a:ext cx="5842508" cy="146050"/>
+          <p:cNvPr id="8" name="text-7"/>
+          <p:cNvSpPr txBox="1"/>
+          <p:nvPr/>
+        </p:nvSpPr>
+        <p:spPr>
+          <a:xfrm rot="-84000">
+            <a:off x="632743" y="2603683"/>
+            <a:ext cx="2672207" cy="146050"/>
           </a:xfrm>
           <a:prstGeom prst="rect">
             <a:avLst/>
@@ -2794,7 +2856,7 @@
                 <a:ea typeface="IBM Plex Mono" pitchFamily="34" charset="-122"/>
                 <a:cs typeface="IBM Plex Mono" pitchFamily="34" charset="-120"/>
               </a:rPr>
-              <a:t>2</a:t>
+              <a:t>РЕШАЕШЬ ТЫ</a:t>
             </a:r>
             <a:endParaRPr lang="en-US" sz="900" dirty="0"/>
           </a:p>
@@ -2802,33 +2864,75 @@
       </p:sp>
       <p:sp>
         <p:nvSpPr>
-          <p:cNvPr id="12" name="text-11"/>
-          <p:cNvSpPr txBox="1"/>
-          <p:nvPr/>
-        </p:nvSpPr>
-        <p:spPr>
-          <a:xfrm rot="60000">
-            <a:off x="671271" y="3302182"/>
-            <a:ext cx="5842508" cy="508000"/>
-          </a:xfrm>
-          <a:prstGeom prst="rect">
-            <a:avLst/>
-          </a:prstGeom>
-          <a:noFill/>
-          <a:ln/>
-        </p:spPr>
-        <p:txBody>
-          <a:bodyPr wrap="square" lIns="0" tIns="0" rIns="0" bIns="0" rtlCol="0" anchor="t"/>
-          <a:lstStyle/>
-          <a:p>
-            <a:pPr algn="l" indent="0" marL="0">
-              <a:lnSpc>
-                <a:spcPts val="2000"/>
-              </a:lnSpc>
-              <a:buNone/>
-            </a:pPr>
-            <a:r>
-              <a:rPr lang="en-US" sz="1450" dirty="0">
+          <p:cNvPr id="9" name="text-8"/>
+          <p:cNvSpPr txBox="1"/>
+          <p:nvPr/>
+        </p:nvSpPr>
+        <p:spPr>
+          <a:xfrm rot="-84000">
+            <a:off x="640515" y="2801033"/>
+            <a:ext cx="2672207" cy="387350"/>
+          </a:xfrm>
+          <a:prstGeom prst="rect">
+            <a:avLst/>
+          </a:prstGeom>
+          <a:noFill/>
+          <a:ln/>
+        </p:spPr>
+        <p:txBody>
+          <a:bodyPr wrap="square" lIns="0" tIns="0" rIns="0" bIns="0" rtlCol="0" anchor="t"/>
+          <a:lstStyle/>
+          <a:p>
+            <a:pPr algn="l" indent="0" marL="0">
+              <a:lnSpc>
+                <a:spcPts val="3060"/>
+              </a:lnSpc>
+              <a:buNone/>
+            </a:pPr>
+            <a:r>
+              <a:rPr lang="en-US" sz="3000" i="1" dirty="0">
+                <a:solidFill>
+                  <a:srgbClr val="0A0A0A"/>
+                </a:solidFill>
+                <a:latin typeface="Noto Serif Display Light" pitchFamily="34" charset="0"/>
+                <a:ea typeface="Noto Serif Display Light" pitchFamily="34" charset="-122"/>
+                <a:cs typeface="Noto Serif Display Light" pitchFamily="34" charset="-120"/>
+              </a:rPr>
+              <a:t>Score Choice</a:t>
+            </a:r>
+            <a:endParaRPr lang="en-US" sz="3000" dirty="0"/>
+          </a:p>
+        </p:txBody>
+      </p:sp>
+      <p:sp>
+        <p:nvSpPr>
+          <p:cNvPr id="10" name="text-9"/>
+          <p:cNvSpPr txBox="1"/>
+          <p:nvPr/>
+        </p:nvSpPr>
+        <p:spPr>
+          <a:xfrm rot="-84000">
+            <a:off x="655782" y="3276501"/>
+            <a:ext cx="2672207" cy="685800"/>
+          </a:xfrm>
+          <a:prstGeom prst="rect">
+            <a:avLst/>
+          </a:prstGeom>
+          <a:noFill/>
+          <a:ln/>
+        </p:spPr>
+        <p:txBody>
+          <a:bodyPr wrap="square" lIns="0" tIns="0" rIns="0" bIns="0" rtlCol="0" anchor="t"/>
+          <a:lstStyle/>
+          <a:p>
+            <a:pPr algn="l" indent="0" marL="0">
+              <a:lnSpc>
+                <a:spcPts val="1790"/>
+              </a:lnSpc>
+              <a:buNone/>
+            </a:pPr>
+            <a:r>
+              <a:rPr lang="en-US" sz="1300" dirty="0">
                 <a:solidFill>
                   <a:srgbClr val="0A0A0A"/>
                 </a:solidFill>
@@ -2836,201 +2940,173 @@
                 <a:ea typeface="Geist" pitchFamily="34" charset="-122"/>
                 <a:cs typeface="Geist" pitchFamily="34" charset="-120"/>
               </a:rPr>
-              <a:t>На каждой сдаче старайся по </a:t>
-            </a:r>
-            <a:pPr algn="l" indent="0" marL="0">
-              <a:lnSpc>
-                <a:spcPts val="2000"/>
-              </a:lnSpc>
-              <a:buNone/>
-            </a:pPr>
-            <a:r>
-              <a:rPr lang="en-US" sz="1450" b="1" dirty="0">
-                <a:solidFill>
-                  <a:srgbClr val="0A0A0A"/>
+              <a:t>Функция College Board: ты сам выбираешь, результаты каких дат отправить.</a:t>
+            </a:r>
+            <a:endParaRPr lang="en-US" sz="1300" dirty="0"/>
+          </a:p>
+        </p:txBody>
+      </p:sp>
+      <p:sp>
+        <p:nvSpPr>
+          <p:cNvPr id="11" name="shape-10"/>
+          <p:cNvSpPr/>
+          <p:nvPr/>
+        </p:nvSpPr>
+        <p:spPr>
+          <a:xfrm rot="84000">
+            <a:off x="3498850" y="2412405"/>
+            <a:ext cx="2901950" cy="1752600"/>
+          </a:xfrm>
+          <a:prstGeom prst="roundRect">
+            <a:avLst>
+              <a:gd name="adj" fmla="val 9420"/>
+            </a:avLst>
+          </a:prstGeom>
+          <a:solidFill>
+            <a:srgbClr val="0A0A0A"/>
+          </a:solidFill>
+          <a:ln/>
+        </p:spPr>
+      </p:sp>
+      <p:sp>
+        <p:nvSpPr>
+          <p:cNvPr id="12" name="text-11"/>
+          <p:cNvSpPr txBox="1"/>
+          <p:nvPr/>
+        </p:nvSpPr>
+        <p:spPr>
+          <a:xfrm rot="84000">
+            <a:off x="3704307" y="2603683"/>
+            <a:ext cx="2672207" cy="146050"/>
+          </a:xfrm>
+          <a:prstGeom prst="rect">
+            <a:avLst/>
+          </a:prstGeom>
+          <a:noFill/>
+          <a:ln/>
+        </p:spPr>
+        <p:txBody>
+          <a:bodyPr wrap="square" lIns="0" tIns="0" rIns="0" bIns="0" rtlCol="0" anchor="t"/>
+          <a:lstStyle/>
+          <a:p>
+            <a:pPr algn="l" indent="0" marL="0">
+              <a:lnSpc>
+                <a:spcPts val="1080"/>
+              </a:lnSpc>
+              <a:buNone/>
+            </a:pPr>
+            <a:r>
+              <a:rPr lang="en-US" sz="900" spc="140" kern="0" dirty="0">
+                <a:solidFill>
+                  <a:srgbClr val="FAF8F3"/>
+                </a:solidFill>
+                <a:latin typeface="IBM Plex Mono" pitchFamily="34" charset="0"/>
+                <a:ea typeface="IBM Plex Mono" pitchFamily="34" charset="-122"/>
+                <a:cs typeface="IBM Plex Mono" pitchFamily="34" charset="-120"/>
+              </a:rPr>
+              <a:t>РЕШАЕТ ВУЗ</a:t>
+            </a:r>
+            <a:endParaRPr lang="en-US" sz="900" dirty="0"/>
+          </a:p>
+        </p:txBody>
+      </p:sp>
+      <p:sp>
+        <p:nvSpPr>
+          <p:cNvPr id="13" name="text-12"/>
+          <p:cNvSpPr txBox="1"/>
+          <p:nvPr/>
+        </p:nvSpPr>
+        <p:spPr>
+          <a:xfrm rot="84000">
+            <a:off x="3696535" y="2801033"/>
+            <a:ext cx="2672207" cy="387350"/>
+          </a:xfrm>
+          <a:prstGeom prst="rect">
+            <a:avLst/>
+          </a:prstGeom>
+          <a:noFill/>
+          <a:ln/>
+        </p:spPr>
+        <p:txBody>
+          <a:bodyPr wrap="square" lIns="0" tIns="0" rIns="0" bIns="0" rtlCol="0" anchor="t"/>
+          <a:lstStyle/>
+          <a:p>
+            <a:pPr algn="l" indent="0" marL="0">
+              <a:lnSpc>
+                <a:spcPts val="3060"/>
+              </a:lnSpc>
+              <a:buNone/>
+            </a:pPr>
+            <a:r>
+              <a:rPr lang="en-US" sz="3000" i="1" dirty="0">
+                <a:solidFill>
+                  <a:srgbClr val="FAF8F3"/>
+                </a:solidFill>
+                <a:latin typeface="Noto Serif Display Light" pitchFamily="34" charset="0"/>
+                <a:ea typeface="Noto Serif Display Light" pitchFamily="34" charset="-122"/>
+                <a:cs typeface="Noto Serif Display Light" pitchFamily="34" charset="-120"/>
+              </a:rPr>
+              <a:t>Superscore</a:t>
+            </a:r>
+            <a:endParaRPr lang="en-US" sz="3000" dirty="0"/>
+          </a:p>
+        </p:txBody>
+      </p:sp>
+      <p:sp>
+        <p:nvSpPr>
+          <p:cNvPr id="14" name="text-13"/>
+          <p:cNvSpPr txBox="1"/>
+          <p:nvPr/>
+        </p:nvSpPr>
+        <p:spPr>
+          <a:xfrm rot="84000">
+            <a:off x="3681268" y="3276501"/>
+            <a:ext cx="2672207" cy="685800"/>
+          </a:xfrm>
+          <a:prstGeom prst="rect">
+            <a:avLst/>
+          </a:prstGeom>
+          <a:noFill/>
+          <a:ln/>
+        </p:spPr>
+        <p:txBody>
+          <a:bodyPr wrap="square" lIns="0" tIns="0" rIns="0" bIns="0" rtlCol="0" anchor="t"/>
+          <a:lstStyle/>
+          <a:p>
+            <a:pPr algn="l" indent="0" marL="0">
+              <a:lnSpc>
+                <a:spcPts val="1790"/>
+              </a:lnSpc>
+              <a:buNone/>
+            </a:pPr>
+            <a:r>
+              <a:rPr lang="en-US" sz="1300" dirty="0">
+                <a:solidFill>
+                  <a:srgbClr val="FAF8F3"/>
                 </a:solidFill>
                 <a:latin typeface="Geist" pitchFamily="34" charset="0"/>
                 <a:ea typeface="Geist" pitchFamily="34" charset="-122"/>
                 <a:cs typeface="Geist" pitchFamily="34" charset="-120"/>
               </a:rPr>
-              <a:t>обеим секциям</a:t>
-            </a:r>
-            <a:pPr algn="l" indent="0" marL="0">
-              <a:lnSpc>
-                <a:spcPts val="2000"/>
-              </a:lnSpc>
-              <a:buNone/>
-            </a:pPr>
-            <a:r>
-              <a:rPr lang="en-US" sz="1450" dirty="0">
-                <a:solidFill>
-                  <a:srgbClr val="0A0A0A"/>
-                </a:solidFill>
-                <a:latin typeface="Geist" pitchFamily="34" charset="0"/>
-                <a:ea typeface="Geist" pitchFamily="34" charset="-122"/>
-                <a:cs typeface="Geist" pitchFamily="34" charset="-120"/>
-              </a:rPr>
-              <a:t>. MIT пишет, что большой разрыв между попытками могут учесть.</a:t>
-            </a:r>
-            <a:endParaRPr lang="en-US" sz="1450" dirty="0"/>
-          </a:p>
-        </p:txBody>
-      </p:sp>
-      <p:sp>
-        <p:nvSpPr>
-          <p:cNvPr id="13" name="shape-12"/>
+              <a:t>Вуз складывает твои лучшие секции из всех присланных сдач.</a:t>
+            </a:r>
+            <a:endParaRPr lang="en-US" sz="1300" dirty="0"/>
+          </a:p>
+        </p:txBody>
+      </p:sp>
+      <p:sp>
+        <p:nvSpPr>
+          <p:cNvPr id="15" name="shape-14"/>
           <p:cNvSpPr/>
           <p:nvPr/>
         </p:nvSpPr>
         <p:spPr>
-          <a:xfrm rot="-60000">
-            <a:off x="457200" y="4077097"/>
-            <a:ext cx="5943600" cy="1047750"/>
-          </a:xfrm>
-          <a:prstGeom prst="roundRect">
-            <a:avLst>
-              <a:gd name="adj" fmla="val 16970"/>
-            </a:avLst>
-          </a:prstGeom>
-          <a:solidFill>
-            <a:srgbClr val="0A0A0A"/>
-          </a:solidFill>
-          <a:ln/>
-        </p:spPr>
-      </p:sp>
-      <p:sp>
-        <p:nvSpPr>
-          <p:cNvPr id="14" name="text-13"/>
-          <p:cNvSpPr txBox="1"/>
-          <p:nvPr/>
-        </p:nvSpPr>
-        <p:spPr>
-          <a:xfrm rot="-60000">
-            <a:off x="668111" y="4242141"/>
-            <a:ext cx="5842508" cy="146050"/>
-          </a:xfrm>
-          <a:prstGeom prst="rect">
-            <a:avLst/>
-          </a:prstGeom>
-          <a:noFill/>
-          <a:ln/>
-        </p:spPr>
-        <p:txBody>
-          <a:bodyPr wrap="square" lIns="0" tIns="0" rIns="0" bIns="0" rtlCol="0" anchor="t"/>
-          <a:lstStyle/>
-          <a:p>
-            <a:pPr algn="l" indent="0" marL="0">
-              <a:lnSpc>
-                <a:spcPts val="1080"/>
-              </a:lnSpc>
-              <a:buNone/>
-            </a:pPr>
-            <a:r>
-              <a:rPr lang="en-US" sz="900" spc="140" kern="0" dirty="0">
-                <a:solidFill>
-                  <a:srgbClr val="FAF8F3"/>
-                </a:solidFill>
-                <a:latin typeface="IBM Plex Mono" pitchFamily="34" charset="0"/>
-                <a:ea typeface="IBM Plex Mono" pitchFamily="34" charset="-122"/>
-                <a:cs typeface="IBM Plex Mono" pitchFamily="34" charset="-120"/>
-              </a:rPr>
-              <a:t>3</a:t>
-            </a:r>
-            <a:endParaRPr lang="en-US" sz="900" dirty="0"/>
-          </a:p>
-        </p:txBody>
-      </p:sp>
-      <p:sp>
-        <p:nvSpPr>
-          <p:cNvPr id="15" name="text-14"/>
-          <p:cNvSpPr txBox="1"/>
-          <p:nvPr/>
-        </p:nvSpPr>
-        <p:spPr>
-          <a:xfrm rot="-60000">
-            <a:off x="674929" y="4451731"/>
-            <a:ext cx="5842508" cy="508000"/>
-          </a:xfrm>
-          <a:prstGeom prst="rect">
-            <a:avLst/>
-          </a:prstGeom>
-          <a:noFill/>
-          <a:ln/>
-        </p:spPr>
-        <p:txBody>
-          <a:bodyPr wrap="square" lIns="0" tIns="0" rIns="0" bIns="0" rtlCol="0" anchor="t"/>
-          <a:lstStyle/>
-          <a:p>
-            <a:pPr algn="l" indent="0" marL="0">
-              <a:lnSpc>
-                <a:spcPts val="2000"/>
-              </a:lnSpc>
-              <a:buNone/>
-            </a:pPr>
-            <a:r>
-              <a:rPr lang="en-US" sz="1450" dirty="0">
-                <a:solidFill>
-                  <a:srgbClr val="FAF8F3"/>
-                </a:solidFill>
-                <a:latin typeface="Geist" pitchFamily="34" charset="0"/>
-                <a:ea typeface="Geist" pitchFamily="34" charset="-122"/>
-                <a:cs typeface="Geist" pitchFamily="34" charset="-120"/>
-              </a:rPr>
-              <a:t>Поступаешь в НУ? Целься в </a:t>
-            </a:r>
-            <a:pPr algn="l" indent="0" marL="0">
-              <a:lnSpc>
-                <a:spcPts val="2000"/>
-              </a:lnSpc>
-              <a:buNone/>
-            </a:pPr>
-            <a:r>
-              <a:rPr lang="en-US" sz="1450" b="1" dirty="0">
-                <a:solidFill>
-                  <a:srgbClr val="FAF8F3"/>
-                </a:solidFill>
-                <a:latin typeface="Geist" pitchFamily="34" charset="0"/>
-                <a:ea typeface="Geist" pitchFamily="34" charset="-122"/>
-                <a:cs typeface="Geist" pitchFamily="34" charset="-120"/>
-              </a:rPr>
-              <a:t>лучший общий балл за одну сдачу</a:t>
-            </a:r>
-            <a:pPr algn="l" indent="0" marL="0">
-              <a:lnSpc>
-                <a:spcPts val="2000"/>
-              </a:lnSpc>
-              <a:buNone/>
-            </a:pPr>
-            <a:r>
-              <a:rPr lang="en-US" sz="1450" dirty="0">
-                <a:solidFill>
-                  <a:srgbClr val="FAF8F3"/>
-                </a:solidFill>
-                <a:latin typeface="Geist" pitchFamily="34" charset="0"/>
-                <a:ea typeface="Geist" pitchFamily="34" charset="-122"/>
-                <a:cs typeface="Geist" pitchFamily="34" charset="-120"/>
-              </a:rPr>
-              <a:t>.</a:t>
-            </a:r>
-            <a:endParaRPr lang="en-US" sz="1450" dirty="0"/>
-          </a:p>
-        </p:txBody>
-      </p:sp>
-      <p:sp>
-        <p:nvSpPr>
-          <p:cNvPr id="16" name="shape-15"/>
-          <p:cNvSpPr/>
-          <p:nvPr/>
-        </p:nvSpPr>
-        <p:spPr>
-          <a:xfrm rot="60000">
-            <a:off x="457200" y="5226596"/>
-            <a:ext cx="5943600" cy="793750"/>
-          </a:xfrm>
-          <a:prstGeom prst="roundRect">
-            <a:avLst>
-              <a:gd name="adj" fmla="val 22400"/>
-            </a:avLst>
+          <a:xfrm>
+            <a:off x="457200" y="5081191"/>
+            <a:ext cx="5943600" cy="939800"/>
+          </a:xfrm>
+          <a:prstGeom prst="rect">
+            <a:avLst/>
           </a:prstGeom>
           <a:solidFill>
             <a:srgbClr val="FFFFFF"/>
@@ -3047,40 +3123,1898 @@
       </p:sp>
       <p:sp>
         <p:nvSpPr>
+          <p:cNvPr id="16" name="shape-15"/>
+          <p:cNvSpPr/>
+          <p:nvPr/>
+        </p:nvSpPr>
+        <p:spPr>
+          <a:xfrm rot="-180000">
+            <a:off x="2952750" y="4965700"/>
+            <a:ext cx="952500" cy="279400"/>
+          </a:xfrm>
+          <a:prstGeom prst="rect">
+            <a:avLst/>
+          </a:prstGeom>
+          <a:solidFill>
+            <a:srgbClr val="D5D5D4">
+              <a:alpha val="90000"/>
+            </a:srgbClr>
+          </a:solidFill>
+          <a:ln/>
+        </p:spPr>
+      </p:sp>
+      <p:sp>
+        <p:nvSpPr>
           <p:cNvPr id="17" name="text-16"/>
           <p:cNvSpPr txBox="1"/>
           <p:nvPr/>
         </p:nvSpPr>
         <p:spPr>
-          <a:xfrm rot="60000">
-            <a:off x="675871" y="5391670"/>
-            <a:ext cx="5842508" cy="146050"/>
-          </a:xfrm>
-          <a:prstGeom prst="rect">
-            <a:avLst/>
-          </a:prstGeom>
-          <a:noFill/>
-          <a:ln/>
-        </p:spPr>
-        <p:txBody>
-          <a:bodyPr wrap="square" lIns="0" tIns="0" rIns="0" bIns="0" rtlCol="0" anchor="t"/>
-          <a:lstStyle/>
-          <a:p>
-            <a:pPr algn="l" indent="0" marL="0">
-              <a:lnSpc>
-                <a:spcPts val="1080"/>
-              </a:lnSpc>
-              <a:buNone/>
-            </a:pPr>
-            <a:r>
-              <a:rPr lang="en-US" sz="900" spc="140" kern="0" dirty="0">
-                <a:solidFill>
-                  <a:srgbClr val="5A5852"/>
+          <a:xfrm>
+            <a:off x="723900" y="5322491"/>
+            <a:ext cx="5734812" cy="495300"/>
+          </a:xfrm>
+          <a:prstGeom prst="rect">
+            <a:avLst/>
+          </a:prstGeom>
+          <a:noFill/>
+          <a:ln/>
+        </p:spPr>
+        <p:txBody>
+          <a:bodyPr wrap="square" lIns="0" tIns="0" rIns="0" bIns="0" rtlCol="0" anchor="t"/>
+          <a:lstStyle/>
+          <a:p>
+            <a:pPr algn="l" indent="0" marL="0">
+              <a:lnSpc>
+                <a:spcPts val="1960"/>
+              </a:lnSpc>
+              <a:buNone/>
+            </a:pPr>
+            <a:r>
+              <a:rPr lang="en-US" sz="1400" dirty="0">
+                <a:solidFill>
+                  <a:srgbClr val="2B2A27"/>
+                </a:solidFill>
+                <a:latin typeface="Geist" pitchFamily="34" charset="0"/>
+                <a:ea typeface="Geist" pitchFamily="34" charset="-122"/>
+                <a:cs typeface="Geist" pitchFamily="34" charset="-120"/>
+              </a:rPr>
+              <a:t>Некоторые вузы просят все результаты. MIT, например, просит указать каждую сдачу и сам считает суперскор.</a:t>
+            </a:r>
+            <a:endParaRPr lang="en-US" sz="1400" dirty="0"/>
+          </a:p>
+        </p:txBody>
+      </p:sp>
+      <p:sp>
+        <p:nvSpPr>
+          <p:cNvPr id="18" name="text-17"/>
+          <p:cNvSpPr txBox="1"/>
+          <p:nvPr/>
+        </p:nvSpPr>
+        <p:spPr>
+          <a:xfrm>
+            <a:off x="457845" y="7969250"/>
+            <a:ext cx="895223" cy="171450"/>
+          </a:xfrm>
+          <a:prstGeom prst="rect">
+            <a:avLst/>
+          </a:prstGeom>
+          <a:noFill/>
+          <a:ln/>
+        </p:spPr>
+        <p:txBody>
+          <a:bodyPr wrap="square" lIns="0" tIns="0" rIns="0" bIns="0" rtlCol="0" anchor="t"/>
+          <a:lstStyle/>
+          <a:p>
+            <a:pPr algn="l" indent="0" marL="0">
+              <a:lnSpc>
+                <a:spcPts val="1200"/>
+              </a:lnSpc>
+              <a:buNone/>
+            </a:pPr>
+            <a:r>
+              <a:rPr lang="en-US" sz="1000" spc="140" kern="0" dirty="0">
+                <a:solidFill>
+                  <a:srgbClr val="0A0A0A"/>
                 </a:solidFill>
                 <a:latin typeface="IBM Plex Mono" pitchFamily="34" charset="0"/>
                 <a:ea typeface="IBM Plex Mono" pitchFamily="34" charset="-122"/>
                 <a:cs typeface="IBM Plex Mono" pitchFamily="34" charset="-120"/>
               </a:rPr>
+              <a:t>@NURZYCOM</a:t>
+            </a:r>
+            <a:endParaRPr lang="en-US" sz="1000" dirty="0"/>
+          </a:p>
+        </p:txBody>
+      </p:sp>
+      <p:sp>
+        <p:nvSpPr>
+          <p:cNvPr id="19" name="shape-18"/>
+          <p:cNvSpPr/>
+          <p:nvPr/>
+        </p:nvSpPr>
+        <p:spPr>
+          <a:xfrm>
+            <a:off x="5340945" y="7893050"/>
+            <a:ext cx="1060450" cy="323850"/>
+          </a:xfrm>
+          <a:prstGeom prst="roundRect">
+            <a:avLst>
+              <a:gd name="adj" fmla="val 50000"/>
+            </a:avLst>
+          </a:prstGeom>
+          <a:solidFill>
+            <a:srgbClr val="0A0A0A"/>
+          </a:solidFill>
+          <a:ln/>
+        </p:spPr>
+      </p:sp>
+      <p:sp>
+        <p:nvSpPr>
+          <p:cNvPr id="20" name="text-19"/>
+          <p:cNvSpPr txBox="1"/>
+          <p:nvPr/>
+        </p:nvSpPr>
+        <p:spPr>
+          <a:xfrm>
+            <a:off x="5480645" y="7969250"/>
+            <a:ext cx="599059" cy="171450"/>
+          </a:xfrm>
+          <a:prstGeom prst="rect">
+            <a:avLst/>
+          </a:prstGeom>
+          <a:noFill/>
+          <a:ln/>
+        </p:spPr>
+        <p:txBody>
+          <a:bodyPr wrap="square" lIns="0" tIns="0" rIns="0" bIns="0" rtlCol="0" anchor="t"/>
+          <a:lstStyle/>
+          <a:p>
+            <a:pPr algn="l" indent="0" marL="0">
+              <a:lnSpc>
+                <a:spcPts val="1200"/>
+              </a:lnSpc>
+              <a:buNone/>
+            </a:pPr>
+            <a:r>
+              <a:rPr lang="en-US" sz="1000" spc="140" kern="0" dirty="0">
+                <a:solidFill>
+                  <a:srgbClr val="FAF8F3"/>
+                </a:solidFill>
+                <a:latin typeface="IBM Plex Mono" pitchFamily="34" charset="0"/>
+                <a:ea typeface="IBM Plex Mono" pitchFamily="34" charset="-122"/>
+                <a:cs typeface="IBM Plex Mono" pitchFamily="34" charset="-120"/>
+              </a:rPr>
+              <a:t>ЛИСТАЙ</a:t>
+            </a:r>
+            <a:endParaRPr lang="en-US" sz="1000" dirty="0"/>
+          </a:p>
+        </p:txBody>
+      </p:sp>
+      <p:pic>
+        <p:nvPicPr>
+          <p:cNvPr id="21" name="svg-20" descr="preencoded.png">    </p:cNvPr>
+          <p:cNvPicPr>
+            <a:picLocks noChangeAspect="1"/>
+          </p:cNvPicPr>
+          <p:nvPr/>
+        </p:nvPicPr>
+        <p:blipFill>
+          <a:blip r:embed="rId3"/>
+          <a:stretch>
+            <a:fillRect/>
+          </a:stretch>
+        </p:blipFill>
+        <p:spPr>
+          <a:xfrm>
+            <a:off x="6121400" y="7985125"/>
+            <a:ext cx="139700" cy="139700"/>
+          </a:xfrm>
+          <a:prstGeom prst="rect">
+            <a:avLst/>
+          </a:prstGeom>
+        </p:spPr>
+      </p:pic>
+      <p:sp>
+        <p:nvSpPr>
+          <p:cNvPr id="22" name="text-21"/>
+          <p:cNvSpPr txBox="1"/>
+          <p:nvPr/>
+        </p:nvSpPr>
+        <p:spPr>
+          <a:xfrm>
+            <a:off x="457200" y="7303740"/>
+            <a:ext cx="6300216" cy="266700"/>
+          </a:xfrm>
+          <a:prstGeom prst="rect">
+            <a:avLst/>
+          </a:prstGeom>
+          <a:noFill/>
+          <a:ln/>
+        </p:spPr>
+        <p:txBody>
+          <a:bodyPr wrap="square" lIns="0" tIns="0" rIns="0" bIns="0" rtlCol="0" anchor="t"/>
+          <a:lstStyle/>
+          <a:p>
+            <a:pPr algn="l" indent="0" marL="0">
+              <a:lnSpc>
+                <a:spcPts val="2070"/>
+              </a:lnSpc>
+              <a:buNone/>
+            </a:pPr>
+            <a:r>
+              <a:rPr lang="en-US" sz="1800" i="1" dirty="0">
+                <a:solidFill>
+                  <a:srgbClr val="0A0A0A"/>
+                </a:solidFill>
+                <a:latin typeface="Noto Serif Display Light" pitchFamily="34" charset="0"/>
+                <a:ea typeface="Noto Serif Display Light" pitchFamily="34" charset="-122"/>
+                <a:cs typeface="Noto Serif Display Light" pitchFamily="34" charset="-120"/>
+              </a:rPr>
+              <a:t>осталось выбрать даты</a:t>
+            </a:r>
+            <a:endParaRPr lang="en-US" sz="1800" dirty="0"/>
+          </a:p>
+        </p:txBody>
+      </p:sp>
+    </p:spTree>
+  </p:cSld>
+  <p:clrMapOvr>
+    <a:masterClrMapping/>
+  </p:clrMapOvr>
+</p:sld>
+</file>
+
+<file path=ppt/slides/slide11.xml><?xml version="1.0" encoding="utf-8"?>
+<p:sld xmlns:a="http://schemas.openxmlformats.org/drawingml/2006/main" xmlns:r="http://schemas.openxmlformats.org/officeDocument/2006/relationships" xmlns:p="http://schemas.openxmlformats.org/presentationml/2006/main">
+  <p:cSld name="Slide 11">
+    <p:bg>
+      <p:bgPr>
+        <a:blipFill dpi="0" rotWithShape="1">
+          <a:blip r:embed="rId1">
+            <a:lum/>
+          </a:blip>
+          <a:srcRect/>
+          <a:stretch>
+            <a:fillRect/>
+          </a:stretch>
+        </a:blipFill>
+        <a:effectLst/>
+      </p:bgPr>
+    </p:bg>
+    <p:spTree>
+      <p:nvGrpSpPr>
+        <p:cNvPr id="1" name=""/>
+        <p:cNvGrpSpPr/>
+        <p:nvPr/>
+      </p:nvGrpSpPr>
+      <p:grpSpPr>
+        <a:xfrm>
+          <a:off x="0" y="0"/>
+          <a:ext cx="0" cy="0"/>
+          <a:chOff x="0" y="0"/>
+          <a:chExt cx="0" cy="0"/>
+        </a:xfrm>
+      </p:grpSpPr>
+      <p:sp>
+        <p:nvSpPr>
+          <p:cNvPr id="2" name="shape-1"/>
+          <p:cNvSpPr/>
+          <p:nvPr/>
+        </p:nvSpPr>
+        <p:spPr>
+          <a:xfrm>
+            <a:off x="457200" y="406400"/>
+            <a:ext cx="1397000" cy="323850"/>
+          </a:xfrm>
+          <a:prstGeom prst="roundRect">
+            <a:avLst>
+              <a:gd name="adj" fmla="val 50000"/>
+            </a:avLst>
+          </a:prstGeom>
+          <a:solidFill>
+            <a:srgbClr val="FAF8F3"/>
+          </a:solidFill>
+          <a:ln w="12700">
+            <a:solidFill>
+              <a:srgbClr val="0A0A0A"/>
+            </a:solidFill>
+            <a:prstDash val="solid"/>
+          </a:ln>
+        </p:spPr>
+      </p:sp>
+      <p:pic>
+        <p:nvPicPr>
+          <p:cNvPr id="3" name="svg-2" descr="preencoded.png">    </p:cNvPr>
+          <p:cNvPicPr>
+            <a:picLocks noChangeAspect="1"/>
+          </p:cNvPicPr>
+          <p:nvPr/>
+        </p:nvPicPr>
+        <p:blipFill>
+          <a:blip r:embed="rId2"/>
+          <a:stretch>
+            <a:fillRect/>
+          </a:stretch>
+        </p:blipFill>
+        <p:spPr>
+          <a:xfrm>
+            <a:off x="584200" y="498475"/>
+            <a:ext cx="139700" cy="139700"/>
+          </a:xfrm>
+          <a:prstGeom prst="rect">
+            <a:avLst/>
+          </a:prstGeom>
+        </p:spPr>
+      </p:pic>
+      <p:sp>
+        <p:nvSpPr>
+          <p:cNvPr id="4" name="text-3"/>
+          <p:cNvSpPr txBox="1"/>
+          <p:nvPr/>
+        </p:nvSpPr>
+        <p:spPr>
+          <a:xfrm>
+            <a:off x="787400" y="482600"/>
+            <a:ext cx="996188" cy="171450"/>
+          </a:xfrm>
+          <a:prstGeom prst="rect">
+            <a:avLst/>
+          </a:prstGeom>
+          <a:noFill/>
+          <a:ln/>
+        </p:spPr>
+        <p:txBody>
+          <a:bodyPr wrap="square" lIns="0" tIns="0" rIns="0" bIns="0" rtlCol="0" anchor="t"/>
+          <a:lstStyle/>
+          <a:p>
+            <a:pPr algn="l" indent="0" marL="0">
+              <a:lnSpc>
+                <a:spcPts val="1200"/>
+              </a:lnSpc>
+              <a:buNone/>
+            </a:pPr>
+            <a:r>
+              <a:rPr lang="en-US" sz="1000" spc="140" kern="0" dirty="0">
+                <a:solidFill>
+                  <a:srgbClr val="0A0A0A"/>
+                </a:solidFill>
+                <a:latin typeface="IBM Plex Mono" pitchFamily="34" charset="0"/>
+                <a:ea typeface="IBM Plex Mono" pitchFamily="34" charset="-122"/>
+                <a:cs typeface="IBM Plex Mono" pitchFamily="34" charset="-120"/>
+              </a:rPr>
+              <a:t>SAT · ДАТЫ</a:t>
+            </a:r>
+            <a:endParaRPr lang="en-US" sz="1000" dirty="0"/>
+          </a:p>
+        </p:txBody>
+      </p:sp>
+      <p:sp>
+        <p:nvSpPr>
+          <p:cNvPr id="5" name="text-4"/>
+          <p:cNvSpPr txBox="1"/>
+          <p:nvPr/>
+        </p:nvSpPr>
+        <p:spPr>
+          <a:xfrm>
+            <a:off x="5741640" y="482600"/>
+            <a:ext cx="700024" cy="171450"/>
+          </a:xfrm>
+          <a:prstGeom prst="rect">
+            <a:avLst/>
+          </a:prstGeom>
+          <a:noFill/>
+          <a:ln/>
+        </p:spPr>
+        <p:txBody>
+          <a:bodyPr wrap="square" lIns="0" tIns="0" rIns="0" bIns="0" rtlCol="0" anchor="t"/>
+          <a:lstStyle/>
+          <a:p>
+            <a:pPr algn="l" indent="0" marL="0">
+              <a:lnSpc>
+                <a:spcPts val="1200"/>
+              </a:lnSpc>
+              <a:buNone/>
+            </a:pPr>
+            <a:r>
+              <a:rPr lang="en-US" sz="1000" spc="140" kern="0" dirty="0">
+                <a:solidFill>
+                  <a:srgbClr val="0A0A0A"/>
+                </a:solidFill>
+                <a:latin typeface="IBM Plex Mono" pitchFamily="34" charset="0"/>
+                <a:ea typeface="IBM Plex Mono" pitchFamily="34" charset="-122"/>
+                <a:cs typeface="IBM Plex Mono" pitchFamily="34" charset="-120"/>
+              </a:rPr>
+              <a:t>11 / 12</a:t>
+            </a:r>
+            <a:endParaRPr lang="en-US" sz="1000" dirty="0"/>
+          </a:p>
+        </p:txBody>
+      </p:sp>
+      <p:sp>
+        <p:nvSpPr>
+          <p:cNvPr id="6" name="text-5"/>
+          <p:cNvSpPr txBox="1"/>
+          <p:nvPr/>
+        </p:nvSpPr>
+        <p:spPr>
+          <a:xfrm>
+            <a:off x="457200" y="951458"/>
+            <a:ext cx="6300216" cy="628650"/>
+          </a:xfrm>
+          <a:prstGeom prst="rect">
+            <a:avLst/>
+          </a:prstGeom>
+          <a:noFill/>
+          <a:ln/>
+        </p:spPr>
+        <p:txBody>
+          <a:bodyPr wrap="square" lIns="0" tIns="0" rIns="0" bIns="0" rtlCol="0" anchor="t"/>
+          <a:lstStyle/>
+          <a:p>
+            <a:pPr algn="l" indent="0" marL="0">
+              <a:lnSpc>
+                <a:spcPts val="4280"/>
+              </a:lnSpc>
+              <a:buNone/>
+            </a:pPr>
+            <a:r>
+              <a:rPr lang="en-US" sz="4200" b="1" spc="-150" kern="0" dirty="0">
+                <a:solidFill>
+                  <a:srgbClr val="0A0A0A"/>
+                </a:solidFill>
+                <a:latin typeface="Geist" pitchFamily="34" charset="0"/>
+                <a:ea typeface="Geist" pitchFamily="34" charset="-122"/>
+                <a:cs typeface="Geist" pitchFamily="34" charset="-120"/>
+              </a:rPr>
+              <a:t>Когда </a:t>
+            </a:r>
+            <a:pPr algn="l" indent="0" marL="0">
+              <a:lnSpc>
+                <a:spcPts val="4280"/>
+              </a:lnSpc>
+              <a:buNone/>
+            </a:pPr>
+            <a:r>
+              <a:rPr lang="en-US" sz="4800" i="1" spc="-100" kern="0" dirty="0">
+                <a:solidFill>
+                  <a:srgbClr val="0A0A0A"/>
+                </a:solidFill>
+                <a:latin typeface="Noto Serif Display Light" pitchFamily="34" charset="0"/>
+                <a:ea typeface="Noto Serif Display Light" pitchFamily="34" charset="-122"/>
+                <a:cs typeface="Noto Serif Display Light" pitchFamily="34" charset="-120"/>
+              </a:rPr>
+              <a:t>пересдать</a:t>
+            </a:r>
+            <a:endParaRPr lang="en-US" sz="4200" dirty="0"/>
+          </a:p>
+        </p:txBody>
+      </p:sp>
+      <p:sp>
+        <p:nvSpPr>
+          <p:cNvPr id="7" name="text-6"/>
+          <p:cNvSpPr txBox="1"/>
+          <p:nvPr/>
+        </p:nvSpPr>
+        <p:spPr>
+          <a:xfrm>
+            <a:off x="457696" y="1706066"/>
+            <a:ext cx="5889625" cy="533400"/>
+          </a:xfrm>
+          <a:prstGeom prst="rect">
+            <a:avLst/>
+          </a:prstGeom>
+          <a:noFill/>
+          <a:ln/>
+        </p:spPr>
+        <p:txBody>
+          <a:bodyPr wrap="square" lIns="0" tIns="0" rIns="0" bIns="0" rtlCol="0" anchor="t"/>
+          <a:lstStyle/>
+          <a:p>
+            <a:pPr algn="l" indent="0" marL="0">
+              <a:lnSpc>
+                <a:spcPts val="2100"/>
+              </a:lnSpc>
+              <a:buNone/>
+            </a:pPr>
+            <a:r>
+              <a:rPr lang="en-US" sz="1500" dirty="0">
+                <a:solidFill>
+                  <a:srgbClr val="2B2A27"/>
+                </a:solidFill>
+                <a:latin typeface="Geist" pitchFamily="34" charset="0"/>
+                <a:ea typeface="Geist" pitchFamily="34" charset="-122"/>
+                <a:cs typeface="Geist" pitchFamily="34" charset="-120"/>
+              </a:rPr>
+              <a:t>Даты SAT на 2026–2027 учебный год. Регистрация закрывается примерно за две недели до теста.</a:t>
+            </a:r>
+            <a:endParaRPr lang="en-US" sz="1500" dirty="0"/>
+          </a:p>
+        </p:txBody>
+      </p:sp>
+      <p:sp>
+        <p:nvSpPr>
+          <p:cNvPr id="8" name="shape-7"/>
+          <p:cNvSpPr/>
+          <p:nvPr/>
+        </p:nvSpPr>
+        <p:spPr>
+          <a:xfrm rot="-48000">
+            <a:off x="457200" y="2667000"/>
+            <a:ext cx="5943600" cy="628650"/>
+          </a:xfrm>
+          <a:prstGeom prst="rect">
+            <a:avLst/>
+          </a:prstGeom>
+          <a:solidFill>
+            <a:srgbClr val="0A0A0A"/>
+          </a:solidFill>
+          <a:ln/>
+          <a:effectLst>
+            <a:outerShdw sx="100000" sy="100000" kx="0" ky="0" algn="bl" rotWithShape="0" blurRad="177800" dist="76200" dir="5400000">
+              <a:srgbClr val="000000">
+                <a:alpha val="22000"/>
+              </a:srgbClr>
+            </a:outerShdw>
+          </a:effectLst>
+        </p:spPr>
+      </p:sp>
+      <p:sp>
+        <p:nvSpPr>
+          <p:cNvPr id="9" name="text-8"/>
+          <p:cNvSpPr txBox="1"/>
+          <p:nvPr/>
+        </p:nvSpPr>
+        <p:spPr>
+          <a:xfrm rot="-48000">
+            <a:off x="635161" y="2829042"/>
+            <a:ext cx="2530856" cy="342900"/>
+          </a:xfrm>
+          <a:prstGeom prst="rect">
+            <a:avLst/>
+          </a:prstGeom>
+          <a:noFill/>
+          <a:ln/>
+        </p:spPr>
+        <p:txBody>
+          <a:bodyPr wrap="square" lIns="0" tIns="0" rIns="0" bIns="0" rtlCol="0" anchor="t"/>
+          <a:lstStyle/>
+          <a:p>
+            <a:pPr algn="l" indent="0" marL="0">
+              <a:lnSpc>
+                <a:spcPts val="2700"/>
+              </a:lnSpc>
+              <a:buNone/>
+            </a:pPr>
+            <a:r>
+              <a:rPr lang="en-US" sz="2700" i="1" dirty="0">
+                <a:solidFill>
+                  <a:srgbClr val="FAF8F3"/>
+                </a:solidFill>
+                <a:latin typeface="Noto Serif Display Light" pitchFamily="34" charset="0"/>
+                <a:ea typeface="Noto Serif Display Light" pitchFamily="34" charset="-122"/>
+                <a:cs typeface="Noto Serif Display Light" pitchFamily="34" charset="-120"/>
+              </a:rPr>
+              <a:t>5 декабря 2026</a:t>
+            </a:r>
+            <a:endParaRPr lang="en-US" sz="2700" dirty="0"/>
+          </a:p>
+        </p:txBody>
+      </p:sp>
+      <p:sp>
+        <p:nvSpPr>
+          <p:cNvPr id="10" name="text-9"/>
+          <p:cNvSpPr txBox="1"/>
+          <p:nvPr/>
+        </p:nvSpPr>
+        <p:spPr>
+          <a:xfrm rot="-48000">
+            <a:off x="4129654" y="2933881"/>
+            <a:ext cx="2093341" cy="196850"/>
+          </a:xfrm>
+          <a:prstGeom prst="rect">
+            <a:avLst/>
+          </a:prstGeom>
+          <a:noFill/>
+          <a:ln/>
+        </p:spPr>
+        <p:txBody>
+          <a:bodyPr wrap="square" lIns="0" tIns="0" rIns="0" bIns="0" rtlCol="0" anchor="t"/>
+          <a:lstStyle/>
+          <a:p>
+            <a:pPr algn="r" indent="0" marL="0">
+              <a:lnSpc>
+                <a:spcPts val="1440"/>
+              </a:lnSpc>
+              <a:buNone/>
+            </a:pPr>
+            <a:r>
+              <a:rPr lang="en-US" sz="1200" dirty="0">
+                <a:solidFill>
+                  <a:srgbClr val="FAF8F3"/>
+                </a:solidFill>
+                <a:latin typeface="Geist Medium" pitchFamily="34" charset="0"/>
+                <a:ea typeface="Geist Medium" pitchFamily="34" charset="-122"/>
+                <a:cs typeface="Geist Medium" pitchFamily="34" charset="-120"/>
+              </a:rPr>
+              <a:t>регистрация до 20 ноября</a:t>
+            </a:r>
+            <a:endParaRPr lang="en-US" sz="1200" dirty="0"/>
+          </a:p>
+        </p:txBody>
+      </p:sp>
+      <p:sp>
+        <p:nvSpPr>
+          <p:cNvPr id="11" name="shape-10"/>
+          <p:cNvSpPr/>
+          <p:nvPr/>
+        </p:nvSpPr>
+        <p:spPr>
+          <a:xfrm rot="48000">
+            <a:off x="457200" y="3397250"/>
+            <a:ext cx="5943600" cy="628650"/>
+          </a:xfrm>
+          <a:prstGeom prst="rect">
+            <a:avLst/>
+          </a:prstGeom>
+          <a:solidFill>
+            <a:srgbClr val="FFFFFF"/>
+          </a:solidFill>
+          <a:ln/>
+          <a:effectLst>
+            <a:outerShdw sx="100000" sy="100000" kx="0" ky="0" algn="bl" rotWithShape="0" blurRad="177800" dist="76200" dir="5400000">
+              <a:srgbClr val="000000">
+                <a:alpha val="22000"/>
+              </a:srgbClr>
+            </a:outerShdw>
+          </a:effectLst>
+        </p:spPr>
+      </p:sp>
+      <p:sp>
+        <p:nvSpPr>
+          <p:cNvPr id="12" name="text-11"/>
+          <p:cNvSpPr txBox="1"/>
+          <p:nvPr/>
+        </p:nvSpPr>
+        <p:spPr>
+          <a:xfrm rot="48000">
+            <a:off x="636101" y="3513512"/>
+            <a:ext cx="2362581" cy="342900"/>
+          </a:xfrm>
+          <a:prstGeom prst="rect">
+            <a:avLst/>
+          </a:prstGeom>
+          <a:noFill/>
+          <a:ln/>
+        </p:spPr>
+        <p:txBody>
+          <a:bodyPr wrap="square" lIns="0" tIns="0" rIns="0" bIns="0" rtlCol="0" anchor="t"/>
+          <a:lstStyle/>
+          <a:p>
+            <a:pPr algn="l" indent="0" marL="0">
+              <a:lnSpc>
+                <a:spcPts val="2700"/>
+              </a:lnSpc>
+              <a:buNone/>
+            </a:pPr>
+            <a:r>
+              <a:rPr lang="en-US" sz="2700" i="1" dirty="0">
+                <a:solidFill>
+                  <a:srgbClr val="0A0A0A"/>
+                </a:solidFill>
+                <a:latin typeface="Noto Serif Display Light" pitchFamily="34" charset="0"/>
+                <a:ea typeface="Noto Serif Display Light" pitchFamily="34" charset="-122"/>
+                <a:cs typeface="Noto Serif Display Light" pitchFamily="34" charset="-120"/>
+              </a:rPr>
+              <a:t>6 марта 2027</a:t>
+            </a:r>
+            <a:endParaRPr lang="en-US" sz="2700" dirty="0"/>
+          </a:p>
+        </p:txBody>
+      </p:sp>
+      <p:sp>
+        <p:nvSpPr>
+          <p:cNvPr id="13" name="text-12"/>
+          <p:cNvSpPr txBox="1"/>
+          <p:nvPr/>
+        </p:nvSpPr>
+        <p:spPr>
+          <a:xfrm rot="48000">
+            <a:off x="4046907" y="3714024"/>
+            <a:ext cx="2174113" cy="196850"/>
+          </a:xfrm>
+          <a:prstGeom prst="rect">
+            <a:avLst/>
+          </a:prstGeom>
+          <a:noFill/>
+          <a:ln/>
+        </p:spPr>
+        <p:txBody>
+          <a:bodyPr wrap="square" lIns="0" tIns="0" rIns="0" bIns="0" rtlCol="0" anchor="t"/>
+          <a:lstStyle/>
+          <a:p>
+            <a:pPr algn="r" indent="0" marL="0">
+              <a:lnSpc>
+                <a:spcPts val="1440"/>
+              </a:lnSpc>
+              <a:buNone/>
+            </a:pPr>
+            <a:r>
+              <a:rPr lang="en-US" sz="1200" dirty="0">
+                <a:solidFill>
+                  <a:srgbClr val="0A0A0A"/>
+                </a:solidFill>
+                <a:latin typeface="Geist Medium" pitchFamily="34" charset="0"/>
+                <a:ea typeface="Geist Medium" pitchFamily="34" charset="-122"/>
+                <a:cs typeface="Geist Medium" pitchFamily="34" charset="-120"/>
+              </a:rPr>
+              <a:t>регистрация до 19 февраля</a:t>
+            </a:r>
+            <a:endParaRPr lang="en-US" sz="1200" dirty="0"/>
+          </a:p>
+        </p:txBody>
+      </p:sp>
+      <p:sp>
+        <p:nvSpPr>
+          <p:cNvPr id="14" name="shape-13"/>
+          <p:cNvSpPr/>
+          <p:nvPr/>
+        </p:nvSpPr>
+        <p:spPr>
+          <a:xfrm rot="-48000">
+            <a:off x="457200" y="4127500"/>
+            <a:ext cx="5943600" cy="628650"/>
+          </a:xfrm>
+          <a:prstGeom prst="rect">
+            <a:avLst/>
+          </a:prstGeom>
+          <a:solidFill>
+            <a:srgbClr val="FFFFFF"/>
+          </a:solidFill>
+          <a:ln/>
+          <a:effectLst>
+            <a:outerShdw sx="100000" sy="100000" kx="0" ky="0" algn="bl" rotWithShape="0" blurRad="177800" dist="76200" dir="5400000">
+              <a:srgbClr val="000000">
+                <a:alpha val="22000"/>
+              </a:srgbClr>
+            </a:outerShdw>
+          </a:effectLst>
+        </p:spPr>
+      </p:sp>
+      <p:sp>
+        <p:nvSpPr>
+          <p:cNvPr id="15" name="text-14"/>
+          <p:cNvSpPr txBox="1"/>
+          <p:nvPr/>
+        </p:nvSpPr>
+        <p:spPr>
+          <a:xfrm rot="-48000">
+            <a:off x="636332" y="4293870"/>
+            <a:ext cx="1871218" cy="342900"/>
+          </a:xfrm>
+          <a:prstGeom prst="rect">
+            <a:avLst/>
+          </a:prstGeom>
+          <a:noFill/>
+          <a:ln/>
+        </p:spPr>
+        <p:txBody>
+          <a:bodyPr wrap="square" lIns="0" tIns="0" rIns="0" bIns="0" rtlCol="0" anchor="t"/>
+          <a:lstStyle/>
+          <a:p>
+            <a:pPr algn="l" indent="0" marL="0">
+              <a:lnSpc>
+                <a:spcPts val="2700"/>
+              </a:lnSpc>
+              <a:buNone/>
+            </a:pPr>
+            <a:r>
+              <a:rPr lang="en-US" sz="2700" i="1" dirty="0">
+                <a:solidFill>
+                  <a:srgbClr val="0A0A0A"/>
+                </a:solidFill>
+                <a:latin typeface="Noto Serif Display Light" pitchFamily="34" charset="0"/>
+                <a:ea typeface="Noto Serif Display Light" pitchFamily="34" charset="-122"/>
+                <a:cs typeface="Noto Serif Display Light" pitchFamily="34" charset="-120"/>
+              </a:rPr>
+              <a:t>1 мая 2027</a:t>
+            </a:r>
+            <a:endParaRPr lang="en-US" sz="2700" dirty="0"/>
+          </a:p>
+        </p:txBody>
+      </p:sp>
+      <p:sp>
+        <p:nvSpPr>
+          <p:cNvPr id="16" name="text-15"/>
+          <p:cNvSpPr txBox="1"/>
+          <p:nvPr/>
+        </p:nvSpPr>
+        <p:spPr>
+          <a:xfrm rot="-48000">
+            <a:off x="4183301" y="4394029"/>
+            <a:ext cx="2039493" cy="196850"/>
+          </a:xfrm>
+          <a:prstGeom prst="rect">
+            <a:avLst/>
+          </a:prstGeom>
+          <a:noFill/>
+          <a:ln/>
+        </p:spPr>
+        <p:txBody>
+          <a:bodyPr wrap="square" lIns="0" tIns="0" rIns="0" bIns="0" rtlCol="0" anchor="t"/>
+          <a:lstStyle/>
+          <a:p>
+            <a:pPr algn="r" indent="0" marL="0">
+              <a:lnSpc>
+                <a:spcPts val="1440"/>
+              </a:lnSpc>
+              <a:buNone/>
+            </a:pPr>
+            <a:r>
+              <a:rPr lang="en-US" sz="1200" dirty="0">
+                <a:solidFill>
+                  <a:srgbClr val="0A0A0A"/>
+                </a:solidFill>
+                <a:latin typeface="Geist Medium" pitchFamily="34" charset="0"/>
+                <a:ea typeface="Geist Medium" pitchFamily="34" charset="-122"/>
+                <a:cs typeface="Geist Medium" pitchFamily="34" charset="-120"/>
+              </a:rPr>
+              <a:t>регистрация до 16 апреля</a:t>
+            </a:r>
+            <a:endParaRPr lang="en-US" sz="1200" dirty="0"/>
+          </a:p>
+        </p:txBody>
+      </p:sp>
+      <p:sp>
+        <p:nvSpPr>
+          <p:cNvPr id="17" name="shape-16"/>
+          <p:cNvSpPr/>
+          <p:nvPr/>
+        </p:nvSpPr>
+        <p:spPr>
+          <a:xfrm rot="48000">
+            <a:off x="457200" y="4857750"/>
+            <a:ext cx="5943600" cy="628650"/>
+          </a:xfrm>
+          <a:prstGeom prst="rect">
+            <a:avLst/>
+          </a:prstGeom>
+          <a:solidFill>
+            <a:srgbClr val="FFFFFF"/>
+          </a:solidFill>
+          <a:ln/>
+          <a:effectLst>
+            <a:outerShdw sx="100000" sy="100000" kx="0" ky="0" algn="bl" rotWithShape="0" blurRad="177800" dist="76200" dir="5400000">
+              <a:srgbClr val="000000">
+                <a:alpha val="22000"/>
+              </a:srgbClr>
+            </a:outerShdw>
+          </a:effectLst>
+        </p:spPr>
+      </p:sp>
+      <p:sp>
+        <p:nvSpPr>
+          <p:cNvPr id="18" name="text-17"/>
+          <p:cNvSpPr txBox="1"/>
+          <p:nvPr/>
+        </p:nvSpPr>
+        <p:spPr>
+          <a:xfrm rot="48000">
+            <a:off x="636759" y="4972071"/>
+            <a:ext cx="2066417" cy="342900"/>
+          </a:xfrm>
+          <a:prstGeom prst="rect">
+            <a:avLst/>
+          </a:prstGeom>
+          <a:noFill/>
+          <a:ln/>
+        </p:spPr>
+        <p:txBody>
+          <a:bodyPr wrap="square" lIns="0" tIns="0" rIns="0" bIns="0" rtlCol="0" anchor="t"/>
+          <a:lstStyle/>
+          <a:p>
+            <a:pPr algn="l" indent="0" marL="0">
+              <a:lnSpc>
+                <a:spcPts val="2700"/>
+              </a:lnSpc>
+              <a:buNone/>
+            </a:pPr>
+            <a:r>
+              <a:rPr lang="en-US" sz="2700" i="1" dirty="0">
+                <a:solidFill>
+                  <a:srgbClr val="0A0A0A"/>
+                </a:solidFill>
+                <a:latin typeface="Noto Serif Display Light" pitchFamily="34" charset="0"/>
+                <a:ea typeface="Noto Serif Display Light" pitchFamily="34" charset="-122"/>
+                <a:cs typeface="Noto Serif Display Light" pitchFamily="34" charset="-120"/>
+              </a:rPr>
+              <a:t>5 июня 2027</a:t>
+            </a:r>
+            <a:endParaRPr lang="en-US" sz="2700" dirty="0"/>
+          </a:p>
+        </p:txBody>
+      </p:sp>
+      <p:sp>
+        <p:nvSpPr>
+          <p:cNvPr id="19" name="text-18"/>
+          <p:cNvSpPr txBox="1"/>
+          <p:nvPr/>
+        </p:nvSpPr>
+        <p:spPr>
+          <a:xfrm rot="48000">
+            <a:off x="4438130" y="5177107"/>
+            <a:ext cx="1783715" cy="196850"/>
+          </a:xfrm>
+          <a:prstGeom prst="rect">
+            <a:avLst/>
+          </a:prstGeom>
+          <a:noFill/>
+          <a:ln/>
+        </p:spPr>
+        <p:txBody>
+          <a:bodyPr wrap="square" lIns="0" tIns="0" rIns="0" bIns="0" rtlCol="0" anchor="t"/>
+          <a:lstStyle/>
+          <a:p>
+            <a:pPr algn="r" indent="0" marL="0">
+              <a:lnSpc>
+                <a:spcPts val="1440"/>
+              </a:lnSpc>
+              <a:buNone/>
+            </a:pPr>
+            <a:r>
+              <a:rPr lang="en-US" sz="1200" dirty="0">
+                <a:solidFill>
+                  <a:srgbClr val="0A0A0A"/>
+                </a:solidFill>
+                <a:latin typeface="Geist Medium" pitchFamily="34" charset="0"/>
+                <a:ea typeface="Geist Medium" pitchFamily="34" charset="-122"/>
+                <a:cs typeface="Geist Medium" pitchFamily="34" charset="-120"/>
+              </a:rPr>
+              <a:t>регистрация до 21 мая</a:t>
+            </a:r>
+            <a:endParaRPr lang="en-US" sz="1200" dirty="0"/>
+          </a:p>
+        </p:txBody>
+      </p:sp>
+      <p:sp>
+        <p:nvSpPr>
+          <p:cNvPr id="20" name="text-19"/>
+          <p:cNvSpPr txBox="1"/>
+          <p:nvPr/>
+        </p:nvSpPr>
+        <p:spPr>
+          <a:xfrm>
+            <a:off x="457200" y="6222305"/>
+            <a:ext cx="6300216" cy="406400"/>
+          </a:xfrm>
+          <a:prstGeom prst="rect">
+            <a:avLst/>
+          </a:prstGeom>
+          <a:noFill/>
+          <a:ln/>
+        </p:spPr>
+        <p:txBody>
+          <a:bodyPr wrap="square" lIns="0" tIns="0" rIns="0" bIns="0" rtlCol="0" anchor="t"/>
+          <a:lstStyle/>
+          <a:p>
+            <a:pPr algn="l" indent="0" marL="0">
+              <a:lnSpc>
+                <a:spcPts val="1600"/>
+              </a:lnSpc>
+              <a:buNone/>
+            </a:pPr>
+            <a:r>
+              <a:rPr lang="en-US" sz="1100" spc="40" kern="0" dirty="0">
+                <a:solidFill>
+                  <a:srgbClr val="5A5852"/>
+                </a:solidFill>
+                <a:latin typeface="IBM Plex Mono" pitchFamily="34" charset="0"/>
+                <a:ea typeface="IBM Plex Mono" pitchFamily="34" charset="-122"/>
+                <a:cs typeface="IBM Plex Mono" pitchFamily="34" charset="-120"/>
+              </a:rPr>
+              <a:t>по сайту College Board, октябрь 2026. Есть поздняя регистрация, но за доплату</a:t>
+            </a:r>
+            <a:endParaRPr lang="en-US" sz="1100" dirty="0"/>
+          </a:p>
+        </p:txBody>
+      </p:sp>
+      <p:sp>
+        <p:nvSpPr>
+          <p:cNvPr id="21" name="text-20"/>
+          <p:cNvSpPr txBox="1"/>
+          <p:nvPr/>
+        </p:nvSpPr>
+        <p:spPr>
+          <a:xfrm>
+            <a:off x="457845" y="7969250"/>
+            <a:ext cx="895223" cy="171450"/>
+          </a:xfrm>
+          <a:prstGeom prst="rect">
+            <a:avLst/>
+          </a:prstGeom>
+          <a:noFill/>
+          <a:ln/>
+        </p:spPr>
+        <p:txBody>
+          <a:bodyPr wrap="square" lIns="0" tIns="0" rIns="0" bIns="0" rtlCol="0" anchor="t"/>
+          <a:lstStyle/>
+          <a:p>
+            <a:pPr algn="l" indent="0" marL="0">
+              <a:lnSpc>
+                <a:spcPts val="1200"/>
+              </a:lnSpc>
+              <a:buNone/>
+            </a:pPr>
+            <a:r>
+              <a:rPr lang="en-US" sz="1000" spc="140" kern="0" dirty="0">
+                <a:solidFill>
+                  <a:srgbClr val="0A0A0A"/>
+                </a:solidFill>
+                <a:latin typeface="IBM Plex Mono" pitchFamily="34" charset="0"/>
+                <a:ea typeface="IBM Plex Mono" pitchFamily="34" charset="-122"/>
+                <a:cs typeface="IBM Plex Mono" pitchFamily="34" charset="-120"/>
+              </a:rPr>
+              <a:t>@NURZYCOM</a:t>
+            </a:r>
+            <a:endParaRPr lang="en-US" sz="1000" dirty="0"/>
+          </a:p>
+        </p:txBody>
+      </p:sp>
+      <p:sp>
+        <p:nvSpPr>
+          <p:cNvPr id="22" name="shape-21"/>
+          <p:cNvSpPr/>
+          <p:nvPr/>
+        </p:nvSpPr>
+        <p:spPr>
+          <a:xfrm>
+            <a:off x="5340945" y="7893050"/>
+            <a:ext cx="1060450" cy="323850"/>
+          </a:xfrm>
+          <a:prstGeom prst="roundRect">
+            <a:avLst>
+              <a:gd name="adj" fmla="val 50000"/>
+            </a:avLst>
+          </a:prstGeom>
+          <a:solidFill>
+            <a:srgbClr val="0A0A0A"/>
+          </a:solidFill>
+          <a:ln/>
+        </p:spPr>
+      </p:sp>
+      <p:sp>
+        <p:nvSpPr>
+          <p:cNvPr id="23" name="text-22"/>
+          <p:cNvSpPr txBox="1"/>
+          <p:nvPr/>
+        </p:nvSpPr>
+        <p:spPr>
+          <a:xfrm>
+            <a:off x="5480645" y="7969250"/>
+            <a:ext cx="599059" cy="171450"/>
+          </a:xfrm>
+          <a:prstGeom prst="rect">
+            <a:avLst/>
+          </a:prstGeom>
+          <a:noFill/>
+          <a:ln/>
+        </p:spPr>
+        <p:txBody>
+          <a:bodyPr wrap="square" lIns="0" tIns="0" rIns="0" bIns="0" rtlCol="0" anchor="t"/>
+          <a:lstStyle/>
+          <a:p>
+            <a:pPr algn="l" indent="0" marL="0">
+              <a:lnSpc>
+                <a:spcPts val="1200"/>
+              </a:lnSpc>
+              <a:buNone/>
+            </a:pPr>
+            <a:r>
+              <a:rPr lang="en-US" sz="1000" spc="140" kern="0" dirty="0">
+                <a:solidFill>
+                  <a:srgbClr val="FAF8F3"/>
+                </a:solidFill>
+                <a:latin typeface="IBM Plex Mono" pitchFamily="34" charset="0"/>
+                <a:ea typeface="IBM Plex Mono" pitchFamily="34" charset="-122"/>
+                <a:cs typeface="IBM Plex Mono" pitchFamily="34" charset="-120"/>
+              </a:rPr>
+              <a:t>ЛИСТАЙ</a:t>
+            </a:r>
+            <a:endParaRPr lang="en-US" sz="1000" dirty="0"/>
+          </a:p>
+        </p:txBody>
+      </p:sp>
+      <p:pic>
+        <p:nvPicPr>
+          <p:cNvPr id="24" name="svg-23" descr="preencoded.png">    </p:cNvPr>
+          <p:cNvPicPr>
+            <a:picLocks noChangeAspect="1"/>
+          </p:cNvPicPr>
+          <p:nvPr/>
+        </p:nvPicPr>
+        <p:blipFill>
+          <a:blip r:embed="rId3"/>
+          <a:stretch>
+            <a:fillRect/>
+          </a:stretch>
+        </p:blipFill>
+        <p:spPr>
+          <a:xfrm>
+            <a:off x="6121400" y="7985125"/>
+            <a:ext cx="139700" cy="139700"/>
+          </a:xfrm>
+          <a:prstGeom prst="rect">
+            <a:avLst/>
+          </a:prstGeom>
+        </p:spPr>
+      </p:pic>
+      <p:sp>
+        <p:nvSpPr>
+          <p:cNvPr id="25" name="text-24"/>
+          <p:cNvSpPr txBox="1"/>
+          <p:nvPr/>
+        </p:nvSpPr>
+        <p:spPr>
+          <a:xfrm>
+            <a:off x="457200" y="7303740"/>
+            <a:ext cx="6300216" cy="266700"/>
+          </a:xfrm>
+          <a:prstGeom prst="rect">
+            <a:avLst/>
+          </a:prstGeom>
+          <a:noFill/>
+          <a:ln/>
+        </p:spPr>
+        <p:txBody>
+          <a:bodyPr wrap="square" lIns="0" tIns="0" rIns="0" bIns="0" rtlCol="0" anchor="t"/>
+          <a:lstStyle/>
+          <a:p>
+            <a:pPr algn="l" indent="0" marL="0">
+              <a:lnSpc>
+                <a:spcPts val="2070"/>
+              </a:lnSpc>
+              <a:buNone/>
+            </a:pPr>
+            <a:r>
+              <a:rPr lang="en-US" sz="1800" i="1" dirty="0">
+                <a:solidFill>
+                  <a:srgbClr val="0A0A0A"/>
+                </a:solidFill>
+                <a:latin typeface="Noto Serif Display Light" pitchFamily="34" charset="0"/>
+                <a:ea typeface="Noto Serif Display Light" pitchFamily="34" charset="-122"/>
+                <a:cs typeface="Noto Serif Display Light" pitchFamily="34" charset="-120"/>
+              </a:rPr>
+              <a:t>собрал всё в план</a:t>
+            </a:r>
+            <a:endParaRPr lang="en-US" sz="1800" dirty="0"/>
+          </a:p>
+        </p:txBody>
+      </p:sp>
+    </p:spTree>
+  </p:cSld>
+  <p:clrMapOvr>
+    <a:masterClrMapping/>
+  </p:clrMapOvr>
+</p:sld>
+</file>
+
+<file path=ppt/slides/slide12.xml><?xml version="1.0" encoding="utf-8"?>
+<p:sld xmlns:a="http://schemas.openxmlformats.org/drawingml/2006/main" xmlns:r="http://schemas.openxmlformats.org/officeDocument/2006/relationships" xmlns:p="http://schemas.openxmlformats.org/presentationml/2006/main">
+  <p:cSld name="Slide 12">
+    <p:bg>
+      <p:bgPr>
+        <a:blipFill dpi="0" rotWithShape="1">
+          <a:blip r:embed="rId1">
+            <a:lum/>
+          </a:blip>
+          <a:srcRect/>
+          <a:stretch>
+            <a:fillRect/>
+          </a:stretch>
+        </a:blipFill>
+        <a:effectLst/>
+      </p:bgPr>
+    </p:bg>
+    <p:spTree>
+      <p:nvGrpSpPr>
+        <p:cNvPr id="1" name=""/>
+        <p:cNvGrpSpPr/>
+        <p:nvPr/>
+      </p:nvGrpSpPr>
+      <p:grpSpPr>
+        <a:xfrm>
+          <a:off x="0" y="0"/>
+          <a:ext cx="0" cy="0"/>
+          <a:chOff x="0" y="0"/>
+          <a:chExt cx="0" cy="0"/>
+        </a:xfrm>
+      </p:grpSpPr>
+      <p:sp>
+        <p:nvSpPr>
+          <p:cNvPr id="2" name="shape-1"/>
+          <p:cNvSpPr/>
+          <p:nvPr/>
+        </p:nvSpPr>
+        <p:spPr>
+          <a:xfrm>
+            <a:off x="457200" y="406400"/>
+            <a:ext cx="1397000" cy="323850"/>
+          </a:xfrm>
+          <a:prstGeom prst="roundRect">
+            <a:avLst>
+              <a:gd name="adj" fmla="val 50000"/>
+            </a:avLst>
+          </a:prstGeom>
+          <a:solidFill>
+            <a:srgbClr val="FAF8F3"/>
+          </a:solidFill>
+          <a:ln w="12700">
+            <a:solidFill>
+              <a:srgbClr val="0A0A0A"/>
+            </a:solidFill>
+            <a:prstDash val="solid"/>
+          </a:ln>
+        </p:spPr>
+      </p:sp>
+      <p:pic>
+        <p:nvPicPr>
+          <p:cNvPr id="3" name="svg-2" descr="preencoded.png">    </p:cNvPr>
+          <p:cNvPicPr>
+            <a:picLocks noChangeAspect="1"/>
+          </p:cNvPicPr>
+          <p:nvPr/>
+        </p:nvPicPr>
+        <p:blipFill>
+          <a:blip r:embed="rId2"/>
+          <a:stretch>
+            <a:fillRect/>
+          </a:stretch>
+        </p:blipFill>
+        <p:spPr>
+          <a:xfrm>
+            <a:off x="584200" y="498475"/>
+            <a:ext cx="139700" cy="139700"/>
+          </a:xfrm>
+          <a:prstGeom prst="rect">
+            <a:avLst/>
+          </a:prstGeom>
+        </p:spPr>
+      </p:pic>
+      <p:sp>
+        <p:nvSpPr>
+          <p:cNvPr id="4" name="text-3"/>
+          <p:cNvSpPr txBox="1"/>
+          <p:nvPr/>
+        </p:nvSpPr>
+        <p:spPr>
+          <a:xfrm>
+            <a:off x="787400" y="482600"/>
+            <a:ext cx="996188" cy="171450"/>
+          </a:xfrm>
+          <a:prstGeom prst="rect">
+            <a:avLst/>
+          </a:prstGeom>
+          <a:noFill/>
+          <a:ln/>
+        </p:spPr>
+        <p:txBody>
+          <a:bodyPr wrap="square" lIns="0" tIns="0" rIns="0" bIns="0" rtlCol="0" anchor="t"/>
+          <a:lstStyle/>
+          <a:p>
+            <a:pPr algn="l" indent="0" marL="0">
+              <a:lnSpc>
+                <a:spcPts val="1200"/>
+              </a:lnSpc>
+              <a:buNone/>
+            </a:pPr>
+            <a:r>
+              <a:rPr lang="en-US" sz="1000" spc="140" kern="0" dirty="0">
+                <a:solidFill>
+                  <a:srgbClr val="0A0A0A"/>
+                </a:solidFill>
+                <a:latin typeface="IBM Plex Mono" pitchFamily="34" charset="0"/>
+                <a:ea typeface="IBM Plex Mono" pitchFamily="34" charset="-122"/>
+                <a:cs typeface="IBM Plex Mono" pitchFamily="34" charset="-120"/>
+              </a:rPr>
+              <a:t>SAT · ПЛАН</a:t>
+            </a:r>
+            <a:endParaRPr lang="en-US" sz="1000" dirty="0"/>
+          </a:p>
+        </p:txBody>
+      </p:sp>
+      <p:sp>
+        <p:nvSpPr>
+          <p:cNvPr id="5" name="text-4"/>
+          <p:cNvSpPr txBox="1"/>
+          <p:nvPr/>
+        </p:nvSpPr>
+        <p:spPr>
+          <a:xfrm>
+            <a:off x="5741640" y="482600"/>
+            <a:ext cx="700024" cy="171450"/>
+          </a:xfrm>
+          <a:prstGeom prst="rect">
+            <a:avLst/>
+          </a:prstGeom>
+          <a:noFill/>
+          <a:ln/>
+        </p:spPr>
+        <p:txBody>
+          <a:bodyPr wrap="square" lIns="0" tIns="0" rIns="0" bIns="0" rtlCol="0" anchor="t"/>
+          <a:lstStyle/>
+          <a:p>
+            <a:pPr algn="l" indent="0" marL="0">
+              <a:lnSpc>
+                <a:spcPts val="1200"/>
+              </a:lnSpc>
+              <a:buNone/>
+            </a:pPr>
+            <a:r>
+              <a:rPr lang="en-US" sz="1000" spc="140" kern="0" dirty="0">
+                <a:solidFill>
+                  <a:srgbClr val="0A0A0A"/>
+                </a:solidFill>
+                <a:latin typeface="IBM Plex Mono" pitchFamily="34" charset="0"/>
+                <a:ea typeface="IBM Plex Mono" pitchFamily="34" charset="-122"/>
+                <a:cs typeface="IBM Plex Mono" pitchFamily="34" charset="-120"/>
+              </a:rPr>
+              <a:t>12 / 12</a:t>
+            </a:r>
+            <a:endParaRPr lang="en-US" sz="1000" dirty="0"/>
+          </a:p>
+        </p:txBody>
+      </p:sp>
+      <p:sp>
+        <p:nvSpPr>
+          <p:cNvPr id="6" name="text-5"/>
+          <p:cNvSpPr txBox="1"/>
+          <p:nvPr/>
+        </p:nvSpPr>
+        <p:spPr>
+          <a:xfrm>
+            <a:off x="457200" y="951458"/>
+            <a:ext cx="6300216" cy="628650"/>
+          </a:xfrm>
+          <a:prstGeom prst="rect">
+            <a:avLst/>
+          </a:prstGeom>
+          <a:noFill/>
+          <a:ln/>
+        </p:spPr>
+        <p:txBody>
+          <a:bodyPr wrap="square" lIns="0" tIns="0" rIns="0" bIns="0" rtlCol="0" anchor="t"/>
+          <a:lstStyle/>
+          <a:p>
+            <a:pPr algn="l" indent="0" marL="0">
+              <a:lnSpc>
+                <a:spcPts val="4280"/>
+              </a:lnSpc>
+              <a:buNone/>
+            </a:pPr>
+            <a:r>
+              <a:rPr lang="en-US" sz="4200" b="1" spc="-150" kern="0" dirty="0">
+                <a:solidFill>
+                  <a:srgbClr val="0A0A0A"/>
+                </a:solidFill>
+                <a:latin typeface="Geist" pitchFamily="34" charset="0"/>
+                <a:ea typeface="Geist" pitchFamily="34" charset="-122"/>
+                <a:cs typeface="Geist" pitchFamily="34" charset="-120"/>
+              </a:rPr>
+              <a:t>План на </a:t>
+            </a:r>
+            <a:pPr algn="l" indent="0" marL="0">
+              <a:lnSpc>
+                <a:spcPts val="4280"/>
+              </a:lnSpc>
+              <a:buNone/>
+            </a:pPr>
+            <a:r>
+              <a:rPr lang="en-US" sz="4800" i="1" spc="-100" kern="0" dirty="0">
+                <a:solidFill>
+                  <a:srgbClr val="0A0A0A"/>
+                </a:solidFill>
+                <a:latin typeface="Noto Serif Display Light" pitchFamily="34" charset="0"/>
+                <a:ea typeface="Noto Serif Display Light" pitchFamily="34" charset="-122"/>
+                <a:cs typeface="Noto Serif Display Light" pitchFamily="34" charset="-120"/>
+              </a:rPr>
+              <a:t>две сдачи</a:t>
+            </a:r>
+            <a:endParaRPr lang="en-US" sz="4200" dirty="0"/>
+          </a:p>
+        </p:txBody>
+      </p:sp>
+      <p:sp>
+        <p:nvSpPr>
+          <p:cNvPr id="7" name="shape-6"/>
+          <p:cNvSpPr/>
+          <p:nvPr/>
+        </p:nvSpPr>
+        <p:spPr>
+          <a:xfrm rot="-60000">
+            <a:off x="457200" y="2032099"/>
+            <a:ext cx="5943600" cy="1047750"/>
+          </a:xfrm>
+          <a:prstGeom prst="roundRect">
+            <a:avLst>
+              <a:gd name="adj" fmla="val 16970"/>
+            </a:avLst>
+          </a:prstGeom>
+          <a:solidFill>
+            <a:srgbClr val="0A0A0A"/>
+          </a:solidFill>
+          <a:ln/>
+        </p:spPr>
+      </p:sp>
+      <p:sp>
+        <p:nvSpPr>
+          <p:cNvPr id="8" name="text-7"/>
+          <p:cNvSpPr txBox="1"/>
+          <p:nvPr/>
+        </p:nvSpPr>
+        <p:spPr>
+          <a:xfrm rot="-60000">
+            <a:off x="668111" y="2197144"/>
+            <a:ext cx="5842508" cy="146050"/>
+          </a:xfrm>
+          <a:prstGeom prst="rect">
+            <a:avLst/>
+          </a:prstGeom>
+          <a:noFill/>
+          <a:ln/>
+        </p:spPr>
+        <p:txBody>
+          <a:bodyPr wrap="square" lIns="0" tIns="0" rIns="0" bIns="0" rtlCol="0" anchor="t"/>
+          <a:lstStyle/>
+          <a:p>
+            <a:pPr algn="l" indent="0" marL="0">
+              <a:lnSpc>
+                <a:spcPts val="1080"/>
+              </a:lnSpc>
+              <a:buNone/>
+            </a:pPr>
+            <a:r>
+              <a:rPr lang="en-US" sz="900" spc="140" kern="0" dirty="0">
+                <a:solidFill>
+                  <a:srgbClr val="FAF8F3"/>
+                </a:solidFill>
+                <a:latin typeface="IBM Plex Mono" pitchFamily="34" charset="0"/>
+                <a:ea typeface="IBM Plex Mono" pitchFamily="34" charset="-122"/>
+                <a:cs typeface="IBM Plex Mono" pitchFamily="34" charset="-120"/>
+              </a:rPr>
+              <a:t>1</a:t>
+            </a:r>
+            <a:endParaRPr lang="en-US" sz="900" dirty="0"/>
+          </a:p>
+        </p:txBody>
+      </p:sp>
+      <p:sp>
+        <p:nvSpPr>
+          <p:cNvPr id="9" name="text-8"/>
+          <p:cNvSpPr txBox="1"/>
+          <p:nvPr/>
+        </p:nvSpPr>
+        <p:spPr>
+          <a:xfrm rot="-60000">
+            <a:off x="674929" y="2406733"/>
+            <a:ext cx="5842508" cy="508000"/>
+          </a:xfrm>
+          <a:prstGeom prst="rect">
+            <a:avLst/>
+          </a:prstGeom>
+          <a:noFill/>
+          <a:ln/>
+        </p:spPr>
+        <p:txBody>
+          <a:bodyPr wrap="square" lIns="0" tIns="0" rIns="0" bIns="0" rtlCol="0" anchor="t"/>
+          <a:lstStyle/>
+          <a:p>
+            <a:pPr algn="l" indent="0" marL="0">
+              <a:lnSpc>
+                <a:spcPts val="2000"/>
+              </a:lnSpc>
+              <a:buNone/>
+            </a:pPr>
+            <a:r>
+              <a:rPr lang="en-US" sz="1450" dirty="0">
+                <a:solidFill>
+                  <a:srgbClr val="FAF8F3"/>
+                </a:solidFill>
+                <a:latin typeface="Geist" pitchFamily="34" charset="0"/>
+                <a:ea typeface="Geist" pitchFamily="34" charset="-122"/>
+                <a:cs typeface="Geist" pitchFamily="34" charset="-120"/>
+              </a:rPr>
+              <a:t>Нужен высокий балл? Закладывай </a:t>
+            </a:r>
+            <a:pPr algn="l" indent="0" marL="0">
+              <a:lnSpc>
+                <a:spcPts val="2000"/>
+              </a:lnSpc>
+              <a:buNone/>
+            </a:pPr>
+            <a:r>
+              <a:rPr lang="en-US" sz="1450" b="1" dirty="0">
+                <a:solidFill>
+                  <a:srgbClr val="FAF8F3"/>
+                </a:solidFill>
+                <a:latin typeface="Geist" pitchFamily="34" charset="0"/>
+                <a:ea typeface="Geist" pitchFamily="34" charset="-122"/>
+                <a:cs typeface="Geist" pitchFamily="34" charset="-120"/>
+              </a:rPr>
+              <a:t>две попытки</a:t>
+            </a:r>
+            <a:pPr algn="l" indent="0" marL="0">
+              <a:lnSpc>
+                <a:spcPts val="2000"/>
+              </a:lnSpc>
+              <a:buNone/>
+            </a:pPr>
+            <a:r>
+              <a:rPr lang="en-US" sz="1450" dirty="0">
+                <a:solidFill>
+                  <a:srgbClr val="FAF8F3"/>
+                </a:solidFill>
+                <a:latin typeface="Geist" pitchFamily="34" charset="0"/>
+                <a:ea typeface="Geist" pitchFamily="34" charset="-122"/>
+                <a:cs typeface="Geist" pitchFamily="34" charset="-120"/>
+              </a:rPr>
+              <a:t>, например декабрь и март.</a:t>
+            </a:r>
+            <a:endParaRPr lang="en-US" sz="1450" dirty="0"/>
+          </a:p>
+        </p:txBody>
+      </p:sp>
+      <p:sp>
+        <p:nvSpPr>
+          <p:cNvPr id="10" name="shape-9"/>
+          <p:cNvSpPr/>
+          <p:nvPr/>
+        </p:nvSpPr>
+        <p:spPr>
+          <a:xfrm rot="60000">
+            <a:off x="457200" y="3181697"/>
+            <a:ext cx="5943600" cy="1301750"/>
+          </a:xfrm>
+          <a:prstGeom prst="roundRect">
+            <a:avLst>
+              <a:gd name="adj" fmla="val 13659"/>
+            </a:avLst>
+          </a:prstGeom>
+          <a:solidFill>
+            <a:srgbClr val="FFFFFF"/>
+          </a:solidFill>
+          <a:ln/>
+          <a:effectLst>
+            <a:outerShdw sx="100000" sy="100000" kx="0" ky="0" algn="bl" rotWithShape="0" blurRad="177800" dist="76200" dir="5400000">
+              <a:srgbClr val="000000">
+                <a:alpha val="22000"/>
+              </a:srgbClr>
+            </a:outerShdw>
+          </a:effectLst>
+        </p:spPr>
+      </p:sp>
+      <p:sp>
+        <p:nvSpPr>
+          <p:cNvPr id="11" name="text-10"/>
+          <p:cNvSpPr txBox="1"/>
+          <p:nvPr/>
+        </p:nvSpPr>
+        <p:spPr>
+          <a:xfrm rot="60000">
+            <a:off x="680306" y="3346711"/>
+            <a:ext cx="5842508" cy="146050"/>
+          </a:xfrm>
+          <a:prstGeom prst="rect">
+            <a:avLst/>
+          </a:prstGeom>
+          <a:noFill/>
+          <a:ln/>
+        </p:spPr>
+        <p:txBody>
+          <a:bodyPr wrap="square" lIns="0" tIns="0" rIns="0" bIns="0" rtlCol="0" anchor="t"/>
+          <a:lstStyle/>
+          <a:p>
+            <a:pPr algn="l" indent="0" marL="0">
+              <a:lnSpc>
+                <a:spcPts val="1080"/>
+              </a:lnSpc>
+              <a:buNone/>
+            </a:pPr>
+            <a:r>
+              <a:rPr lang="en-US" sz="900" spc="140" kern="0" dirty="0">
+                <a:solidFill>
+                  <a:srgbClr val="5A5852"/>
+                </a:solidFill>
+                <a:latin typeface="IBM Plex Mono" pitchFamily="34" charset="0"/>
+                <a:ea typeface="IBM Plex Mono" pitchFamily="34" charset="-122"/>
+                <a:cs typeface="IBM Plex Mono" pitchFamily="34" charset="-120"/>
+              </a:rPr>
+              <a:t>2</a:t>
+            </a:r>
+            <a:endParaRPr lang="en-US" sz="900" dirty="0"/>
+          </a:p>
+        </p:txBody>
+      </p:sp>
+      <p:sp>
+        <p:nvSpPr>
+          <p:cNvPr id="12" name="text-11"/>
+          <p:cNvSpPr txBox="1"/>
+          <p:nvPr/>
+        </p:nvSpPr>
+        <p:spPr>
+          <a:xfrm rot="60000">
+            <a:off x="671271" y="3556331"/>
+            <a:ext cx="5842508" cy="762000"/>
+          </a:xfrm>
+          <a:prstGeom prst="rect">
+            <a:avLst/>
+          </a:prstGeom>
+          <a:noFill/>
+          <a:ln/>
+        </p:spPr>
+        <p:txBody>
+          <a:bodyPr wrap="square" lIns="0" tIns="0" rIns="0" bIns="0" rtlCol="0" anchor="t"/>
+          <a:lstStyle/>
+          <a:p>
+            <a:pPr algn="l" indent="0" marL="0">
+              <a:lnSpc>
+                <a:spcPts val="2000"/>
+              </a:lnSpc>
+              <a:buNone/>
+            </a:pPr>
+            <a:r>
+              <a:rPr lang="en-US" sz="1450" dirty="0">
+                <a:solidFill>
+                  <a:srgbClr val="0A0A0A"/>
+                </a:solidFill>
+                <a:latin typeface="Geist" pitchFamily="34" charset="0"/>
+                <a:ea typeface="Geist" pitchFamily="34" charset="-122"/>
+                <a:cs typeface="Geist" pitchFamily="34" charset="-120"/>
+              </a:rPr>
+              <a:t>Можно сделать упор на одну секцию, как я. Но </a:t>
+            </a:r>
+            <a:pPr algn="l" indent="0" marL="0">
+              <a:lnSpc>
+                <a:spcPts val="2000"/>
+              </a:lnSpc>
+              <a:buNone/>
+            </a:pPr>
+            <a:r>
+              <a:rPr lang="en-US" sz="1450" b="1" dirty="0">
+                <a:solidFill>
+                  <a:srgbClr val="0A0A0A"/>
+                </a:solidFill>
+                <a:latin typeface="Geist" pitchFamily="34" charset="0"/>
+                <a:ea typeface="Geist" pitchFamily="34" charset="-122"/>
+                <a:cs typeface="Geist" pitchFamily="34" charset="-120"/>
+              </a:rPr>
+              <a:t>не проваливай вторую</a:t>
+            </a:r>
+            <a:pPr algn="l" indent="0" marL="0">
+              <a:lnSpc>
+                <a:spcPts val="2000"/>
+              </a:lnSpc>
+              <a:buNone/>
+            </a:pPr>
+            <a:r>
+              <a:rPr lang="en-US" sz="1450" dirty="0">
+                <a:solidFill>
+                  <a:srgbClr val="0A0A0A"/>
+                </a:solidFill>
+                <a:latin typeface="Geist" pitchFamily="34" charset="0"/>
+                <a:ea typeface="Geist" pitchFamily="34" charset="-122"/>
+                <a:cs typeface="Geist" pitchFamily="34" charset="-120"/>
+              </a:rPr>
+              <a:t>: MIT пишет, что большой разрыв между попытками могут учесть.</a:t>
+            </a:r>
+            <a:endParaRPr lang="en-US" sz="1450" dirty="0"/>
+          </a:p>
+        </p:txBody>
+      </p:sp>
+      <p:sp>
+        <p:nvSpPr>
+          <p:cNvPr id="13" name="shape-12"/>
+          <p:cNvSpPr/>
+          <p:nvPr/>
+        </p:nvSpPr>
+        <p:spPr>
+          <a:xfrm rot="-60000">
+            <a:off x="457200" y="4585295"/>
+            <a:ext cx="5943600" cy="1047750"/>
+          </a:xfrm>
+          <a:prstGeom prst="roundRect">
+            <a:avLst>
+              <a:gd name="adj" fmla="val 16970"/>
+            </a:avLst>
+          </a:prstGeom>
+          <a:solidFill>
+            <a:srgbClr val="0A0A0A"/>
+          </a:solidFill>
+          <a:ln/>
+        </p:spPr>
+      </p:sp>
+      <p:sp>
+        <p:nvSpPr>
+          <p:cNvPr id="14" name="text-13"/>
+          <p:cNvSpPr txBox="1"/>
+          <p:nvPr/>
+        </p:nvSpPr>
+        <p:spPr>
+          <a:xfrm rot="-60000">
+            <a:off x="668111" y="4750340"/>
+            <a:ext cx="5842508" cy="146050"/>
+          </a:xfrm>
+          <a:prstGeom prst="rect">
+            <a:avLst/>
+          </a:prstGeom>
+          <a:noFill/>
+          <a:ln/>
+        </p:spPr>
+        <p:txBody>
+          <a:bodyPr wrap="square" lIns="0" tIns="0" rIns="0" bIns="0" rtlCol="0" anchor="t"/>
+          <a:lstStyle/>
+          <a:p>
+            <a:pPr algn="l" indent="0" marL="0">
+              <a:lnSpc>
+                <a:spcPts val="1080"/>
+              </a:lnSpc>
+              <a:buNone/>
+            </a:pPr>
+            <a:r>
+              <a:rPr lang="en-US" sz="900" spc="140" kern="0" dirty="0">
+                <a:solidFill>
+                  <a:srgbClr val="FAF8F3"/>
+                </a:solidFill>
+                <a:latin typeface="IBM Plex Mono" pitchFamily="34" charset="0"/>
+                <a:ea typeface="IBM Plex Mono" pitchFamily="34" charset="-122"/>
+                <a:cs typeface="IBM Plex Mono" pitchFamily="34" charset="-120"/>
+              </a:rPr>
+              <a:t>3</a:t>
+            </a:r>
+            <a:endParaRPr lang="en-US" sz="900" dirty="0"/>
+          </a:p>
+        </p:txBody>
+      </p:sp>
+      <p:sp>
+        <p:nvSpPr>
+          <p:cNvPr id="15" name="text-14"/>
+          <p:cNvSpPr txBox="1"/>
+          <p:nvPr/>
+        </p:nvSpPr>
+        <p:spPr>
+          <a:xfrm rot="-60000">
+            <a:off x="674929" y="4959929"/>
+            <a:ext cx="5842508" cy="508000"/>
+          </a:xfrm>
+          <a:prstGeom prst="rect">
+            <a:avLst/>
+          </a:prstGeom>
+          <a:noFill/>
+          <a:ln/>
+        </p:spPr>
+        <p:txBody>
+          <a:bodyPr wrap="square" lIns="0" tIns="0" rIns="0" bIns="0" rtlCol="0" anchor="t"/>
+          <a:lstStyle/>
+          <a:p>
+            <a:pPr algn="l" indent="0" marL="0">
+              <a:lnSpc>
+                <a:spcPts val="2000"/>
+              </a:lnSpc>
+              <a:buNone/>
+            </a:pPr>
+            <a:r>
+              <a:rPr lang="en-US" sz="1450" dirty="0">
+                <a:solidFill>
+                  <a:srgbClr val="FAF8F3"/>
+                </a:solidFill>
+                <a:latin typeface="Geist" pitchFamily="34" charset="0"/>
+                <a:ea typeface="Geist" pitchFamily="34" charset="-122"/>
+                <a:cs typeface="Geist" pitchFamily="34" charset="-120"/>
+              </a:rPr>
+              <a:t>Поступаешь в НУ? Целься в </a:t>
+            </a:r>
+            <a:pPr algn="l" indent="0" marL="0">
+              <a:lnSpc>
+                <a:spcPts val="2000"/>
+              </a:lnSpc>
+              <a:buNone/>
+            </a:pPr>
+            <a:r>
+              <a:rPr lang="en-US" sz="1450" b="1" dirty="0">
+                <a:solidFill>
+                  <a:srgbClr val="FAF8F3"/>
+                </a:solidFill>
+                <a:latin typeface="Geist" pitchFamily="34" charset="0"/>
+                <a:ea typeface="Geist" pitchFamily="34" charset="-122"/>
+                <a:cs typeface="Geist" pitchFamily="34" charset="-120"/>
+              </a:rPr>
+              <a:t>лучший общий балл за одну сдачу</a:t>
+            </a:r>
+            <a:pPr algn="l" indent="0" marL="0">
+              <a:lnSpc>
+                <a:spcPts val="2000"/>
+              </a:lnSpc>
+              <a:buNone/>
+            </a:pPr>
+            <a:r>
+              <a:rPr lang="en-US" sz="1450" dirty="0">
+                <a:solidFill>
+                  <a:srgbClr val="FAF8F3"/>
+                </a:solidFill>
+                <a:latin typeface="Geist" pitchFamily="34" charset="0"/>
+                <a:ea typeface="Geist" pitchFamily="34" charset="-122"/>
+                <a:cs typeface="Geist" pitchFamily="34" charset="-120"/>
+              </a:rPr>
+              <a:t> и следи за сроком в 2 года.</a:t>
+            </a:r>
+            <a:endParaRPr lang="en-US" sz="1450" dirty="0"/>
+          </a:p>
+        </p:txBody>
+      </p:sp>
+      <p:sp>
+        <p:nvSpPr>
+          <p:cNvPr id="16" name="shape-15"/>
+          <p:cNvSpPr/>
+          <p:nvPr/>
+        </p:nvSpPr>
+        <p:spPr>
+          <a:xfrm rot="60000">
+            <a:off x="457200" y="5734794"/>
+            <a:ext cx="5943600" cy="793750"/>
+          </a:xfrm>
+          <a:prstGeom prst="roundRect">
+            <a:avLst>
+              <a:gd name="adj" fmla="val 22400"/>
+            </a:avLst>
+          </a:prstGeom>
+          <a:solidFill>
+            <a:srgbClr val="FFFFFF"/>
+          </a:solidFill>
+          <a:ln/>
+          <a:effectLst>
+            <a:outerShdw sx="100000" sy="100000" kx="0" ky="0" algn="bl" rotWithShape="0" blurRad="177800" dist="76200" dir="5400000">
+              <a:srgbClr val="000000">
+                <a:alpha val="22000"/>
+              </a:srgbClr>
+            </a:outerShdw>
+          </a:effectLst>
+        </p:spPr>
+      </p:sp>
+      <p:sp>
+        <p:nvSpPr>
+          <p:cNvPr id="17" name="text-16"/>
+          <p:cNvSpPr txBox="1"/>
+          <p:nvPr/>
+        </p:nvSpPr>
+        <p:spPr>
+          <a:xfrm rot="60000">
+            <a:off x="675871" y="5899869"/>
+            <a:ext cx="5842508" cy="146050"/>
+          </a:xfrm>
+          <a:prstGeom prst="rect">
+            <a:avLst/>
+          </a:prstGeom>
+          <a:noFill/>
+          <a:ln/>
+        </p:spPr>
+        <p:txBody>
+          <a:bodyPr wrap="square" lIns="0" tIns="0" rIns="0" bIns="0" rtlCol="0" anchor="t"/>
+          <a:lstStyle/>
+          <a:p>
+            <a:pPr algn="l" indent="0" marL="0">
+              <a:lnSpc>
+                <a:spcPts val="1080"/>
+              </a:lnSpc>
+              <a:buNone/>
+            </a:pPr>
+            <a:r>
+              <a:rPr lang="en-US" sz="900" spc="140" kern="0" dirty="0">
+                <a:solidFill>
+                  <a:srgbClr val="5A5852"/>
+                </a:solidFill>
+                <a:latin typeface="IBM Plex Mono" pitchFamily="34" charset="0"/>
+                <a:ea typeface="IBM Plex Mono" pitchFamily="34" charset="-122"/>
+                <a:cs typeface="IBM Plex Mono" pitchFamily="34" charset="-120"/>
+              </a:rPr>
               <a:t>4</a:t>
             </a:r>
             <a:endParaRPr lang="en-US" sz="900" dirty="0"/>
@@ -3095,7 +5029,7 @@
         </p:nvSpPr>
         <p:spPr>
           <a:xfrm rot="60000">
-            <a:off x="671271" y="5601230"/>
+            <a:off x="671271" y="6109428"/>
             <a:ext cx="5842508" cy="254000"/>
           </a:xfrm>
           <a:prstGeom prst="rect">
@@ -3444,7 +5378,7 @@
                 <a:ea typeface="IBM Plex Mono" pitchFamily="34" charset="-122"/>
                 <a:cs typeface="IBM Plex Mono" pitchFamily="34" charset="-120"/>
               </a:rPr>
-              <a:t>02 / 10</a:t>
+              <a:t>02 / 12</a:t>
             </a:r>
             <a:endParaRPr lang="en-US" sz="1000" dirty="0"/>
           </a:p>
@@ -4079,7 +6013,7 @@
                 <a:ea typeface="IBM Plex Mono" pitchFamily="34" charset="-122"/>
                 <a:cs typeface="IBM Plex Mono" pitchFamily="34" charset="-120"/>
               </a:rPr>
-              <a:t>03 / 10</a:t>
+              <a:t>03 / 12</a:t>
             </a:r>
             <a:endParaRPr lang="en-US" sz="1000" dirty="0"/>
           </a:p>
@@ -4121,7 +6055,7 @@
                 <a:ea typeface="Geist" pitchFamily="34" charset="-122"/>
                 <a:cs typeface="Geist" pitchFamily="34" charset="-120"/>
               </a:rPr>
-              <a:t>Вуз берёт </a:t>
+              <a:t>Стратегический </a:t>
             </a:r>
             <a:pPr algn="l" indent="0" marL="0">
               <a:lnSpc>
@@ -4138,7 +6072,7 @@
                 <a:ea typeface="Noto Serif Display Light" pitchFamily="34" charset="-122"/>
                 <a:cs typeface="Noto Serif Display Light" pitchFamily="34" charset="-120"/>
               </a:rPr>
-              <a:t>лучшее</a:t>
+              <a:t>ход</a:t>
             </a:r>
             <a:endParaRPr lang="en-US" sz="4200" dirty="0"/>
           </a:p>
@@ -4738,8 +6672,8 @@
         </p:nvSpPr>
         <p:spPr>
           <a:xfrm>
-            <a:off x="338328" y="6413500"/>
-            <a:ext cx="6181344" cy="228600"/>
+            <a:off x="1345388" y="6414740"/>
+            <a:ext cx="4167124" cy="717550"/>
           </a:xfrm>
           <a:prstGeom prst="rect">
             <a:avLst/>
@@ -4753,7 +6687,7 @@
           <a:p>
             <a:pPr algn="ctr" indent="0" marL="0">
               <a:lnSpc>
-                <a:spcPts val="1680"/>
+                <a:spcPts val="1890"/>
               </a:lnSpc>
               <a:buNone/>
             </a:pPr>
@@ -4770,7 +6704,7 @@
             </a:r>
             <a:pPr algn="ctr" indent="0" marL="0">
               <a:lnSpc>
-                <a:spcPts val="1680"/>
+                <a:spcPts val="1890"/>
               </a:lnSpc>
               <a:buNone/>
             </a:pPr>
@@ -4787,7 +6721,7 @@
             </a:r>
             <a:pPr algn="ctr" indent="0" marL="0">
               <a:lnSpc>
-                <a:spcPts val="1680"/>
+                <a:spcPts val="1890"/>
               </a:lnSpc>
               <a:buNone/>
             </a:pPr>
@@ -4800,7 +6734,7 @@
                 <a:ea typeface="Geist" pitchFamily="34" charset="-122"/>
                 <a:cs typeface="Geist" pitchFamily="34" charset="-120"/>
               </a:rPr>
-              <a:t>. Это и есть суперскор.</a:t>
+              <a:t>. Это и есть суперскор: на майском я сфокусировался на Reading &amp; Writing, а на декабрьском на Math.</a:t>
             </a:r>
             <a:endParaRPr lang="en-US" sz="1400" dirty="0"/>
           </a:p>
@@ -4972,7 +6906,7 @@
                 <a:ea typeface="Noto Serif Display Light" pitchFamily="34" charset="-122"/>
                 <a:cs typeface="Noto Serif Display Light" pitchFamily="34" charset="-120"/>
               </a:rPr>
-              <a:t>похоже на лазейку. Но всё началось в 1926-м</a:t>
+              <a:t>Похоже на лазейку? Но всё началось в 1926-м</a:t>
             </a:r>
             <a:endParaRPr lang="en-US" sz="1800" dirty="0"/>
           </a:p>
@@ -5146,7 +7080,7 @@
                 <a:ea typeface="IBM Plex Mono" pitchFamily="34" charset="-122"/>
                 <a:cs typeface="IBM Plex Mono" pitchFamily="34" charset="-120"/>
               </a:rPr>
-              <a:t>04 / 10</a:t>
+              <a:t>04 / 12</a:t>
             </a:r>
             <a:endParaRPr lang="en-US" sz="1000" dirty="0"/>
           </a:p>
@@ -5160,8 +7094,8 @@
         </p:nvSpPr>
         <p:spPr>
           <a:xfrm>
-            <a:off x="457200" y="952798"/>
-            <a:ext cx="6300216" cy="1149350"/>
+            <a:off x="457200" y="951061"/>
+            <a:ext cx="6300216" cy="577850"/>
           </a:xfrm>
           <a:prstGeom prst="rect">
             <a:avLst/>
@@ -5188,7 +7122,7 @@
                 <a:ea typeface="Geist" pitchFamily="34" charset="-122"/>
                 <a:cs typeface="Geist" pitchFamily="34" charset="-120"/>
               </a:rPr>
-              <a:t>Один день, </a:t>
+              <a:t>Вернёмся к </a:t>
             </a:r>
             <a:pPr algn="l" indent="0" marL="0">
               <a:lnSpc>
@@ -5205,7 +7139,7 @@
                 <a:ea typeface="Noto Serif Display Light" pitchFamily="34" charset="-122"/>
                 <a:cs typeface="Noto Serif Display Light" pitchFamily="34" charset="-120"/>
               </a:rPr>
-              <a:t>одна попытка</a:t>
+              <a:t>истокам</a:t>
             </a:r>
             <a:endParaRPr lang="en-US" sz="3900" dirty="0"/>
           </a:p>
@@ -5219,7 +7153,7 @@
         </p:nvSpPr>
         <p:spPr>
           <a:xfrm>
-            <a:off x="457696" y="2229445"/>
+            <a:off x="457696" y="1654473"/>
             <a:ext cx="5889625" cy="800100"/>
           </a:xfrm>
           <a:prstGeom prst="rect">
@@ -5708,7 +7642,7 @@
                 <a:ea typeface="IBM Plex Mono" pitchFamily="34" charset="-122"/>
                 <a:cs typeface="IBM Plex Mono" pitchFamily="34" charset="-120"/>
               </a:rPr>
-              <a:t>05 / 10</a:t>
+              <a:t>05 / 12</a:t>
             </a:r>
             <a:endParaRPr lang="en-US" sz="1000" dirty="0"/>
           </a:p>
@@ -6779,7 +8713,7 @@
                 <a:ea typeface="IBM Plex Mono" pitchFamily="34" charset="-122"/>
                 <a:cs typeface="IBM Plex Mono" pitchFamily="34" charset="-120"/>
               </a:rPr>
-              <a:t>06 / 10</a:t>
+              <a:t>06 / 12</a:t>
             </a:r>
             <a:endParaRPr lang="en-US" sz="1000" dirty="0"/>
           </a:p>
@@ -7541,7 +9475,7 @@
                 <a:ea typeface="IBM Plex Mono" pitchFamily="34" charset="-122"/>
                 <a:cs typeface="IBM Plex Mono" pitchFamily="34" charset="-120"/>
               </a:rPr>
-              <a:t>07 / 10</a:t>
+              <a:t>07 / 12</a:t>
             </a:r>
             <a:endParaRPr lang="en-US" sz="1000" dirty="0"/>
           </a:p>
@@ -8432,7 +10366,7 @@
                 <a:ea typeface="IBM Plex Mono" pitchFamily="34" charset="-122"/>
                 <a:cs typeface="IBM Plex Mono" pitchFamily="34" charset="-120"/>
               </a:rPr>
-              <a:t>08 / 10</a:t>
+              <a:t>08 / 12</a:t>
             </a:r>
             <a:endParaRPr lang="en-US" sz="1000" dirty="0"/>
           </a:p>
@@ -9057,7 +10991,7 @@
                 <a:ea typeface="Noto Serif Display Light" pitchFamily="34" charset="-122"/>
                 <a:cs typeface="Noto Serif Display Light" pitchFamily="34" charset="-120"/>
               </a:rPr>
-              <a:t>значит, важно, что ты отправляешь</a:t>
+              <a:t>и ещё два правила НУ</a:t>
             </a:r>
             <a:endParaRPr lang="en-US" sz="1800" dirty="0"/>
           </a:p>
@@ -9110,8 +11044,8 @@
         </p:nvSpPr>
         <p:spPr>
           <a:xfrm>
-            <a:off x="458490" y="406400"/>
-            <a:ext cx="2146300" cy="323850"/>
+            <a:off x="456605" y="406400"/>
+            <a:ext cx="1962150" cy="323850"/>
           </a:xfrm>
           <a:prstGeom prst="roundRect">
             <a:avLst>
@@ -9161,8 +11095,8 @@
         </p:nvSpPr>
         <p:spPr>
           <a:xfrm>
-            <a:off x="788690" y="482600"/>
-            <a:ext cx="1790446" cy="171450"/>
+            <a:off x="786805" y="482600"/>
+            <a:ext cx="1595247" cy="171450"/>
           </a:xfrm>
           <a:prstGeom prst="rect">
             <a:avLst/>
@@ -9189,7 +11123,7 @@
                 <a:ea typeface="IBM Plex Mono" pitchFamily="34" charset="-122"/>
                 <a:cs typeface="IBM Plex Mono" pitchFamily="34" charset="-120"/>
               </a:rPr>
-              <a:t>SAT · SCORE CHOICE</a:t>
+              <a:t>SAT · ПРАВИЛА НУ</a:t>
             </a:r>
             <a:endParaRPr lang="en-US" sz="1000" dirty="0"/>
           </a:p>
@@ -9231,7 +11165,7 @@
                 <a:ea typeface="IBM Plex Mono" pitchFamily="34" charset="-122"/>
                 <a:cs typeface="IBM Plex Mono" pitchFamily="34" charset="-120"/>
               </a:rPr>
-              <a:t>09 / 10</a:t>
+              <a:t>09 / 12</a:t>
             </a:r>
             <a:endParaRPr lang="en-US" sz="1000" dirty="0"/>
           </a:p>
@@ -9245,8 +11179,8 @@
         </p:nvSpPr>
         <p:spPr>
           <a:xfrm>
-            <a:off x="457200" y="953591"/>
-            <a:ext cx="6300216" cy="1250950"/>
+            <a:off x="457200" y="951458"/>
+            <a:ext cx="6300216" cy="628650"/>
           </a:xfrm>
           <a:prstGeom prst="rect">
             <a:avLst/>
@@ -9273,7 +11207,7 @@
                 <a:ea typeface="Geist" pitchFamily="34" charset="-122"/>
                 <a:cs typeface="Geist" pitchFamily="34" charset="-120"/>
               </a:rPr>
-              <a:t>Ты выбираешь, </a:t>
+              <a:t>Ещё два правила </a:t>
             </a:r>
             <a:pPr algn="l" indent="0" marL="0">
               <a:lnSpc>
@@ -9290,7 +11224,7 @@
                 <a:ea typeface="Noto Serif Display Light" pitchFamily="34" charset="-122"/>
                 <a:cs typeface="Noto Serif Display Light" pitchFamily="34" charset="-120"/>
               </a:rPr>
-              <a:t>вуз считает</a:t>
+              <a:t>НУ</a:t>
             </a:r>
             <a:endParaRPr lang="en-US" sz="4200" dirty="0"/>
           </a:p>
@@ -9303,14 +11237,160 @@
           <p:nvPr/>
         </p:nvSpPr>
         <p:spPr>
-          <a:xfrm rot="-84000">
-            <a:off x="457200" y="2412405"/>
-            <a:ext cx="2901950" cy="1752600"/>
+          <a:xfrm rot="-72000">
+            <a:off x="457200" y="2095153"/>
+            <a:ext cx="5943600" cy="1327150"/>
           </a:xfrm>
           <a:prstGeom prst="roundRect">
             <a:avLst>
-              <a:gd name="adj" fmla="val 9420"/>
+              <a:gd name="adj" fmla="val 13397"/>
             </a:avLst>
+          </a:prstGeom>
+          <a:solidFill>
+            <a:srgbClr val="0A0A0A"/>
+          </a:solidFill>
+          <a:ln/>
+        </p:spPr>
+      </p:sp>
+      <p:sp>
+        <p:nvSpPr>
+          <p:cNvPr id="8" name="text-7"/>
+          <p:cNvSpPr txBox="1"/>
+          <p:nvPr/>
+        </p:nvSpPr>
+        <p:spPr>
+          <a:xfrm rot="-72000">
+            <a:off x="690395" y="2298785"/>
+            <a:ext cx="5788660" cy="146050"/>
+          </a:xfrm>
+          <a:prstGeom prst="rect">
+            <a:avLst/>
+          </a:prstGeom>
+          <a:noFill/>
+          <a:ln/>
+        </p:spPr>
+        <p:txBody>
+          <a:bodyPr wrap="square" lIns="0" tIns="0" rIns="0" bIns="0" rtlCol="0" anchor="t"/>
+          <a:lstStyle/>
+          <a:p>
+            <a:pPr algn="l" indent="0" marL="0">
+              <a:lnSpc>
+                <a:spcPts val="1080"/>
+              </a:lnSpc>
+              <a:buNone/>
+            </a:pPr>
+            <a:r>
+              <a:rPr lang="en-US" sz="900" spc="140" kern="0" dirty="0">
+                <a:solidFill>
+                  <a:srgbClr val="FAF8F3"/>
+                </a:solidFill>
+                <a:latin typeface="IBM Plex Mono" pitchFamily="34" charset="0"/>
+                <a:ea typeface="IBM Plex Mono" pitchFamily="34" charset="-122"/>
+                <a:cs typeface="IBM Plex Mono" pitchFamily="34" charset="-120"/>
+              </a:rPr>
+              <a:t>ПРАВИЛО 1</a:t>
+            </a:r>
+            <a:endParaRPr lang="en-US" sz="900" dirty="0"/>
+          </a:p>
+        </p:txBody>
+      </p:sp>
+      <p:sp>
+        <p:nvSpPr>
+          <p:cNvPr id="9" name="text-8"/>
+          <p:cNvSpPr txBox="1"/>
+          <p:nvPr/>
+        </p:nvSpPr>
+        <p:spPr>
+          <a:xfrm rot="-72000">
+            <a:off x="697328" y="2496406"/>
+            <a:ext cx="5788660" cy="412750"/>
+          </a:xfrm>
+          <a:prstGeom prst="rect">
+            <a:avLst/>
+          </a:prstGeom>
+          <a:noFill/>
+          <a:ln/>
+        </p:spPr>
+        <p:txBody>
+          <a:bodyPr wrap="square" lIns="0" tIns="0" rIns="0" bIns="0" rtlCol="0" anchor="t"/>
+          <a:lstStyle/>
+          <a:p>
+            <a:pPr algn="l" indent="0" marL="0">
+              <a:lnSpc>
+                <a:spcPts val="3260"/>
+              </a:lnSpc>
+              <a:buNone/>
+            </a:pPr>
+            <a:r>
+              <a:rPr lang="en-US" sz="3200" i="1" dirty="0">
+                <a:solidFill>
+                  <a:srgbClr val="FAF8F3"/>
+                </a:solidFill>
+                <a:latin typeface="Noto Serif Display Light" pitchFamily="34" charset="0"/>
+                <a:ea typeface="Noto Serif Display Light" pitchFamily="34" charset="-122"/>
+                <a:cs typeface="Noto Serif Display Light" pitchFamily="34" charset="-120"/>
+              </a:rPr>
+              <a:t>Только цифровой SAT</a:t>
+            </a:r>
+            <a:endParaRPr lang="en-US" sz="3200" dirty="0"/>
+          </a:p>
+        </p:txBody>
+      </p:sp>
+      <p:sp>
+        <p:nvSpPr>
+          <p:cNvPr id="10" name="text-9"/>
+          <p:cNvSpPr txBox="1"/>
+          <p:nvPr/>
+        </p:nvSpPr>
+        <p:spPr>
+          <a:xfrm rot="-72000">
+            <a:off x="705566" y="2972222"/>
+            <a:ext cx="5788660" cy="247650"/>
+          </a:xfrm>
+          <a:prstGeom prst="rect">
+            <a:avLst/>
+          </a:prstGeom>
+          <a:noFill/>
+          <a:ln/>
+        </p:spPr>
+        <p:txBody>
+          <a:bodyPr wrap="square" lIns="0" tIns="0" rIns="0" bIns="0" rtlCol="0" anchor="t"/>
+          <a:lstStyle/>
+          <a:p>
+            <a:pPr algn="l" indent="0" marL="0">
+              <a:lnSpc>
+                <a:spcPts val="1930"/>
+              </a:lnSpc>
+              <a:buNone/>
+            </a:pPr>
+            <a:r>
+              <a:rPr lang="en-US" sz="1400" dirty="0">
+                <a:solidFill>
+                  <a:srgbClr val="FAF8F3"/>
+                </a:solidFill>
+                <a:latin typeface="Geist" pitchFamily="34" charset="0"/>
+                <a:ea typeface="Geist" pitchFamily="34" charset="-122"/>
+                <a:cs typeface="Geist" pitchFamily="34" charset="-120"/>
+              </a:rPr>
+              <a:t>Бумажные результаты в конкурсе не учитывают.</a:t>
+            </a:r>
+            <a:endParaRPr lang="en-US" sz="1400" dirty="0"/>
+          </a:p>
+        </p:txBody>
+      </p:sp>
+      <p:sp>
+        <p:nvSpPr>
+          <p:cNvPr id="11" name="shape-10"/>
+          <p:cNvSpPr/>
+          <p:nvPr/>
+        </p:nvSpPr>
+        <p:spPr>
+          <a:xfrm rot="72000">
+            <a:off x="457200" y="3560515"/>
+            <a:ext cx="5943600" cy="1631950"/>
+          </a:xfrm>
+          <a:prstGeom prst="rect">
+            <a:avLst/>
           </a:prstGeom>
           <a:solidFill>
             <a:srgbClr val="FFFFFF"/>
@@ -9327,314 +11407,13 @@
       </p:sp>
       <p:sp>
         <p:nvSpPr>
-          <p:cNvPr id="8" name="text-7"/>
-          <p:cNvSpPr txBox="1"/>
-          <p:nvPr/>
-        </p:nvSpPr>
-        <p:spPr>
-          <a:xfrm rot="-84000">
-            <a:off x="632743" y="2603683"/>
-            <a:ext cx="2672207" cy="146050"/>
-          </a:xfrm>
-          <a:prstGeom prst="rect">
-            <a:avLst/>
-          </a:prstGeom>
-          <a:noFill/>
-          <a:ln/>
-        </p:spPr>
-        <p:txBody>
-          <a:bodyPr wrap="square" lIns="0" tIns="0" rIns="0" bIns="0" rtlCol="0" anchor="t"/>
-          <a:lstStyle/>
-          <a:p>
-            <a:pPr algn="l" indent="0" marL="0">
-              <a:lnSpc>
-                <a:spcPts val="1080"/>
-              </a:lnSpc>
-              <a:buNone/>
-            </a:pPr>
-            <a:r>
-              <a:rPr lang="en-US" sz="900" spc="140" kern="0" dirty="0">
-                <a:solidFill>
-                  <a:srgbClr val="5A5852"/>
-                </a:solidFill>
-                <a:latin typeface="IBM Plex Mono" pitchFamily="34" charset="0"/>
-                <a:ea typeface="IBM Plex Mono" pitchFamily="34" charset="-122"/>
-                <a:cs typeface="IBM Plex Mono" pitchFamily="34" charset="-120"/>
-              </a:rPr>
-              <a:t>РЕШАЕШЬ ТЫ</a:t>
-            </a:r>
-            <a:endParaRPr lang="en-US" sz="900" dirty="0"/>
-          </a:p>
-        </p:txBody>
-      </p:sp>
-      <p:sp>
-        <p:nvSpPr>
-          <p:cNvPr id="9" name="text-8"/>
-          <p:cNvSpPr txBox="1"/>
-          <p:nvPr/>
-        </p:nvSpPr>
-        <p:spPr>
-          <a:xfrm rot="-84000">
-            <a:off x="640515" y="2801033"/>
-            <a:ext cx="2672207" cy="387350"/>
-          </a:xfrm>
-          <a:prstGeom prst="rect">
-            <a:avLst/>
-          </a:prstGeom>
-          <a:noFill/>
-          <a:ln/>
-        </p:spPr>
-        <p:txBody>
-          <a:bodyPr wrap="square" lIns="0" tIns="0" rIns="0" bIns="0" rtlCol="0" anchor="t"/>
-          <a:lstStyle/>
-          <a:p>
-            <a:pPr algn="l" indent="0" marL="0">
-              <a:lnSpc>
-                <a:spcPts val="3060"/>
-              </a:lnSpc>
-              <a:buNone/>
-            </a:pPr>
-            <a:r>
-              <a:rPr lang="en-US" sz="3000" i="1" dirty="0">
-                <a:solidFill>
-                  <a:srgbClr val="0A0A0A"/>
-                </a:solidFill>
-                <a:latin typeface="Noto Serif Display Light" pitchFamily="34" charset="0"/>
-                <a:ea typeface="Noto Serif Display Light" pitchFamily="34" charset="-122"/>
-                <a:cs typeface="Noto Serif Display Light" pitchFamily="34" charset="-120"/>
-              </a:rPr>
-              <a:t>Score Choice</a:t>
-            </a:r>
-            <a:endParaRPr lang="en-US" sz="3000" dirty="0"/>
-          </a:p>
-        </p:txBody>
-      </p:sp>
-      <p:sp>
-        <p:nvSpPr>
-          <p:cNvPr id="10" name="text-9"/>
-          <p:cNvSpPr txBox="1"/>
-          <p:nvPr/>
-        </p:nvSpPr>
-        <p:spPr>
-          <a:xfrm rot="-84000">
-            <a:off x="655782" y="3276501"/>
-            <a:ext cx="2672207" cy="685800"/>
-          </a:xfrm>
-          <a:prstGeom prst="rect">
-            <a:avLst/>
-          </a:prstGeom>
-          <a:noFill/>
-          <a:ln/>
-        </p:spPr>
-        <p:txBody>
-          <a:bodyPr wrap="square" lIns="0" tIns="0" rIns="0" bIns="0" rtlCol="0" anchor="t"/>
-          <a:lstStyle/>
-          <a:p>
-            <a:pPr algn="l" indent="0" marL="0">
-              <a:lnSpc>
-                <a:spcPts val="1790"/>
-              </a:lnSpc>
-              <a:buNone/>
-            </a:pPr>
-            <a:r>
-              <a:rPr lang="en-US" sz="1300" dirty="0">
-                <a:solidFill>
-                  <a:srgbClr val="0A0A0A"/>
-                </a:solidFill>
-                <a:latin typeface="Geist" pitchFamily="34" charset="0"/>
-                <a:ea typeface="Geist" pitchFamily="34" charset="-122"/>
-                <a:cs typeface="Geist" pitchFamily="34" charset="-120"/>
-              </a:rPr>
-              <a:t>Функция College Board: ты сам выбираешь, результаты каких дат отправить.</a:t>
-            </a:r>
-            <a:endParaRPr lang="en-US" sz="1300" dirty="0"/>
-          </a:p>
-        </p:txBody>
-      </p:sp>
-      <p:sp>
-        <p:nvSpPr>
-          <p:cNvPr id="11" name="shape-10"/>
+          <p:cNvPr id="12" name="shape-11"/>
           <p:cNvSpPr/>
           <p:nvPr/>
         </p:nvSpPr>
         <p:spPr>
-          <a:xfrm rot="84000">
-            <a:off x="3498850" y="2412405"/>
-            <a:ext cx="2901950" cy="1752600"/>
-          </a:xfrm>
-          <a:prstGeom prst="roundRect">
-            <a:avLst>
-              <a:gd name="adj" fmla="val 9420"/>
-            </a:avLst>
-          </a:prstGeom>
-          <a:solidFill>
-            <a:srgbClr val="0A0A0A"/>
-          </a:solidFill>
-          <a:ln/>
-        </p:spPr>
-      </p:sp>
-      <p:sp>
-        <p:nvSpPr>
-          <p:cNvPr id="12" name="text-11"/>
-          <p:cNvSpPr txBox="1"/>
-          <p:nvPr/>
-        </p:nvSpPr>
-        <p:spPr>
-          <a:xfrm rot="84000">
-            <a:off x="3704307" y="2603683"/>
-            <a:ext cx="2672207" cy="146050"/>
-          </a:xfrm>
-          <a:prstGeom prst="rect">
-            <a:avLst/>
-          </a:prstGeom>
-          <a:noFill/>
-          <a:ln/>
-        </p:spPr>
-        <p:txBody>
-          <a:bodyPr wrap="square" lIns="0" tIns="0" rIns="0" bIns="0" rtlCol="0" anchor="t"/>
-          <a:lstStyle/>
-          <a:p>
-            <a:pPr algn="l" indent="0" marL="0">
-              <a:lnSpc>
-                <a:spcPts val="1080"/>
-              </a:lnSpc>
-              <a:buNone/>
-            </a:pPr>
-            <a:r>
-              <a:rPr lang="en-US" sz="900" spc="140" kern="0" dirty="0">
-                <a:solidFill>
-                  <a:srgbClr val="FAF8F3"/>
-                </a:solidFill>
-                <a:latin typeface="IBM Plex Mono" pitchFamily="34" charset="0"/>
-                <a:ea typeface="IBM Plex Mono" pitchFamily="34" charset="-122"/>
-                <a:cs typeface="IBM Plex Mono" pitchFamily="34" charset="-120"/>
-              </a:rPr>
-              <a:t>РЕШАЕТ ВУЗ</a:t>
-            </a:r>
-            <a:endParaRPr lang="en-US" sz="900" dirty="0"/>
-          </a:p>
-        </p:txBody>
-      </p:sp>
-      <p:sp>
-        <p:nvSpPr>
-          <p:cNvPr id="13" name="text-12"/>
-          <p:cNvSpPr txBox="1"/>
-          <p:nvPr/>
-        </p:nvSpPr>
-        <p:spPr>
-          <a:xfrm rot="84000">
-            <a:off x="3696535" y="2801033"/>
-            <a:ext cx="2672207" cy="387350"/>
-          </a:xfrm>
-          <a:prstGeom prst="rect">
-            <a:avLst/>
-          </a:prstGeom>
-          <a:noFill/>
-          <a:ln/>
-        </p:spPr>
-        <p:txBody>
-          <a:bodyPr wrap="square" lIns="0" tIns="0" rIns="0" bIns="0" rtlCol="0" anchor="t"/>
-          <a:lstStyle/>
-          <a:p>
-            <a:pPr algn="l" indent="0" marL="0">
-              <a:lnSpc>
-                <a:spcPts val="3060"/>
-              </a:lnSpc>
-              <a:buNone/>
-            </a:pPr>
-            <a:r>
-              <a:rPr lang="en-US" sz="3000" i="1" dirty="0">
-                <a:solidFill>
-                  <a:srgbClr val="FAF8F3"/>
-                </a:solidFill>
-                <a:latin typeface="Noto Serif Display Light" pitchFamily="34" charset="0"/>
-                <a:ea typeface="Noto Serif Display Light" pitchFamily="34" charset="-122"/>
-                <a:cs typeface="Noto Serif Display Light" pitchFamily="34" charset="-120"/>
-              </a:rPr>
-              <a:t>Superscore</a:t>
-            </a:r>
-            <a:endParaRPr lang="en-US" sz="3000" dirty="0"/>
-          </a:p>
-        </p:txBody>
-      </p:sp>
-      <p:sp>
-        <p:nvSpPr>
-          <p:cNvPr id="14" name="text-13"/>
-          <p:cNvSpPr txBox="1"/>
-          <p:nvPr/>
-        </p:nvSpPr>
-        <p:spPr>
-          <a:xfrm rot="84000">
-            <a:off x="3681268" y="3276501"/>
-            <a:ext cx="2672207" cy="685800"/>
-          </a:xfrm>
-          <a:prstGeom prst="rect">
-            <a:avLst/>
-          </a:prstGeom>
-          <a:noFill/>
-          <a:ln/>
-        </p:spPr>
-        <p:txBody>
-          <a:bodyPr wrap="square" lIns="0" tIns="0" rIns="0" bIns="0" rtlCol="0" anchor="t"/>
-          <a:lstStyle/>
-          <a:p>
-            <a:pPr algn="l" indent="0" marL="0">
-              <a:lnSpc>
-                <a:spcPts val="1790"/>
-              </a:lnSpc>
-              <a:buNone/>
-            </a:pPr>
-            <a:r>
-              <a:rPr lang="en-US" sz="1300" dirty="0">
-                <a:solidFill>
-                  <a:srgbClr val="FAF8F3"/>
-                </a:solidFill>
-                <a:latin typeface="Geist" pitchFamily="34" charset="0"/>
-                <a:ea typeface="Geist" pitchFamily="34" charset="-122"/>
-                <a:cs typeface="Geist" pitchFamily="34" charset="-120"/>
-              </a:rPr>
-              <a:t>Вуз складывает твои лучшие секции из всех присланных сдач.</a:t>
-            </a:r>
-            <a:endParaRPr lang="en-US" sz="1300" dirty="0"/>
-          </a:p>
-        </p:txBody>
-      </p:sp>
-      <p:sp>
-        <p:nvSpPr>
-          <p:cNvPr id="15" name="shape-14"/>
-          <p:cNvSpPr/>
-          <p:nvPr/>
-        </p:nvSpPr>
-        <p:spPr>
-          <a:xfrm>
-            <a:off x="457200" y="5081191"/>
-            <a:ext cx="5943600" cy="939800"/>
-          </a:xfrm>
-          <a:prstGeom prst="rect">
-            <a:avLst/>
-          </a:prstGeom>
-          <a:solidFill>
-            <a:srgbClr val="FFFFFF"/>
-          </a:solidFill>
-          <a:ln/>
-          <a:effectLst>
-            <a:outerShdw sx="100000" sy="100000" kx="0" ky="0" algn="bl" rotWithShape="0" blurRad="177800" dist="76200" dir="5400000">
-              <a:srgbClr val="000000">
-                <a:alpha val="22000"/>
-              </a:srgbClr>
-            </a:outerShdw>
-          </a:effectLst>
-        </p:spPr>
-      </p:sp>
-      <p:sp>
-        <p:nvSpPr>
-          <p:cNvPr id="16" name="shape-15"/>
-          <p:cNvSpPr/>
-          <p:nvPr/>
-        </p:nvSpPr>
-        <p:spPr>
-          <a:xfrm rot="-180000">
-            <a:off x="2952750" y="4965700"/>
+          <a:xfrm rot="-108000">
+            <a:off x="2969283" y="3447529"/>
             <a:ext cx="952500" cy="279400"/>
           </a:xfrm>
           <a:prstGeom prst="rect">
@@ -9650,13 +11429,97 @@
       </p:sp>
       <p:sp>
         <p:nvSpPr>
-          <p:cNvPr id="17" name="text-16"/>
-          <p:cNvSpPr txBox="1"/>
-          <p:nvPr/>
-        </p:nvSpPr>
-        <p:spPr>
-          <a:xfrm>
-            <a:off x="723900" y="5322491"/>
+          <p:cNvPr id="13" name="text-12"/>
+          <p:cNvSpPr txBox="1"/>
+          <p:nvPr/>
+        </p:nvSpPr>
+        <p:spPr>
+          <a:xfrm rot="72000">
+            <a:off x="734382" y="3803065"/>
+            <a:ext cx="5734812" cy="146050"/>
+          </a:xfrm>
+          <a:prstGeom prst="rect">
+            <a:avLst/>
+          </a:prstGeom>
+          <a:noFill/>
+          <a:ln/>
+        </p:spPr>
+        <p:txBody>
+          <a:bodyPr wrap="square" lIns="0" tIns="0" rIns="0" bIns="0" rtlCol="0" anchor="t"/>
+          <a:lstStyle/>
+          <a:p>
+            <a:pPr algn="l" indent="0" marL="0">
+              <a:lnSpc>
+                <a:spcPts val="1080"/>
+              </a:lnSpc>
+              <a:buNone/>
+            </a:pPr>
+            <a:r>
+              <a:rPr lang="en-US" sz="900" spc="140" kern="0" dirty="0">
+                <a:solidFill>
+                  <a:srgbClr val="5A5852"/>
+                </a:solidFill>
+                <a:latin typeface="IBM Plex Mono" pitchFamily="34" charset="0"/>
+                <a:ea typeface="IBM Plex Mono" pitchFamily="34" charset="-122"/>
+                <a:cs typeface="IBM Plex Mono" pitchFamily="34" charset="-120"/>
+              </a:rPr>
+              <a:t>ПРАВИЛО 2</a:t>
+            </a:r>
+            <a:endParaRPr lang="en-US" sz="900" dirty="0"/>
+          </a:p>
+        </p:txBody>
+      </p:sp>
+      <p:sp>
+        <p:nvSpPr>
+          <p:cNvPr id="14" name="text-13"/>
+          <p:cNvSpPr txBox="1"/>
+          <p:nvPr/>
+        </p:nvSpPr>
+        <p:spPr>
+          <a:xfrm rot="72000">
+            <a:off x="727449" y="4000686"/>
+            <a:ext cx="5734812" cy="412750"/>
+          </a:xfrm>
+          <a:prstGeom prst="rect">
+            <a:avLst/>
+          </a:prstGeom>
+          <a:noFill/>
+          <a:ln/>
+        </p:spPr>
+        <p:txBody>
+          <a:bodyPr wrap="square" lIns="0" tIns="0" rIns="0" bIns="0" rtlCol="0" anchor="t"/>
+          <a:lstStyle/>
+          <a:p>
+            <a:pPr algn="l" indent="0" marL="0">
+              <a:lnSpc>
+                <a:spcPts val="3260"/>
+              </a:lnSpc>
+              <a:buNone/>
+            </a:pPr>
+            <a:r>
+              <a:rPr lang="en-US" sz="3200" i="1" dirty="0">
+                <a:solidFill>
+                  <a:srgbClr val="0A0A0A"/>
+                </a:solidFill>
+                <a:latin typeface="Noto Serif Display Light" pitchFamily="34" charset="0"/>
+                <a:ea typeface="Noto Serif Display Light" pitchFamily="34" charset="-122"/>
+                <a:cs typeface="Noto Serif Display Light" pitchFamily="34" charset="-120"/>
+              </a:rPr>
+              <a:t>Срок 2 года</a:t>
+            </a:r>
+            <a:endParaRPr lang="en-US" sz="3200" dirty="0"/>
+          </a:p>
+        </p:txBody>
+      </p:sp>
+      <p:sp>
+        <p:nvSpPr>
+          <p:cNvPr id="15" name="text-14"/>
+          <p:cNvSpPr txBox="1"/>
+          <p:nvPr/>
+        </p:nvSpPr>
+        <p:spPr>
+          <a:xfrm rot="72000">
+            <a:off x="716302" y="4491553"/>
             <a:ext cx="5734812" cy="495300"/>
           </a:xfrm>
           <a:prstGeom prst="rect">
@@ -9684,7 +11547,7 @@
                 <a:ea typeface="Geist" pitchFamily="34" charset="-122"/>
                 <a:cs typeface="Geist" pitchFamily="34" charset="-120"/>
               </a:rPr>
-              <a:t>Некоторые вузы просят все результаты. MIT, например, просит указать каждую сдачу и сам считает суперскор.</a:t>
+              <a:t>Сертификат действует два года с даты сдачи и должен быть действителен на 1 августа года поступления.</a:t>
             </a:r>
             <a:endParaRPr lang="en-US" sz="1400" dirty="0"/>
           </a:p>
@@ -9692,7 +11555,49 @@
       </p:sp>
       <p:sp>
         <p:nvSpPr>
-          <p:cNvPr id="18" name="text-17"/>
+          <p:cNvPr id="16" name="text-15"/>
+          <p:cNvSpPr txBox="1"/>
+          <p:nvPr/>
+        </p:nvSpPr>
+        <p:spPr>
+          <a:xfrm rot="-90000">
+            <a:off x="457200" y="5713710"/>
+            <a:ext cx="6300216" cy="520700"/>
+          </a:xfrm>
+          <a:prstGeom prst="rect">
+            <a:avLst/>
+          </a:prstGeom>
+          <a:noFill/>
+          <a:ln/>
+        </p:spPr>
+        <p:txBody>
+          <a:bodyPr wrap="square" lIns="0" tIns="0" rIns="0" bIns="0" rtlCol="0" anchor="t"/>
+          <a:lstStyle/>
+          <a:p>
+            <a:pPr algn="l" indent="0" marL="0">
+              <a:lnSpc>
+                <a:spcPts val="2040"/>
+              </a:lnSpc>
+              <a:buNone/>
+            </a:pPr>
+            <a:r>
+              <a:rPr lang="en-US" sz="1700" i="1" dirty="0">
+                <a:solidFill>
+                  <a:srgbClr val="0A0A0A"/>
+                </a:solidFill>
+                <a:latin typeface="Noto Serif Display Light" pitchFamily="34" charset="0"/>
+                <a:ea typeface="Noto Serif Display Light" pitchFamily="34" charset="-122"/>
+                <a:cs typeface="Noto Serif Display Light" pitchFamily="34" charset="-120"/>
+              </a:rPr>
+              <a:t>сдал в мае 2025? Для поступления в 2027 уже не подойдёт: срок истечёт в мае 2027</a:t>
+            </a:r>
+            <a:endParaRPr lang="en-US" sz="1700" dirty="0"/>
+          </a:p>
+        </p:txBody>
+      </p:sp>
+      <p:sp>
+        <p:nvSpPr>
+          <p:cNvPr id="17" name="text-16"/>
           <p:cNvSpPr txBox="1"/>
           <p:nvPr/>
         </p:nvSpPr>
@@ -9734,7 +11639,7 @@
       </p:sp>
       <p:sp>
         <p:nvSpPr>
-          <p:cNvPr id="19" name="shape-18"/>
+          <p:cNvPr id="18" name="shape-17"/>
           <p:cNvSpPr/>
           <p:nvPr/>
         </p:nvSpPr>
@@ -9756,7 +11661,7 @@
       </p:sp>
       <p:sp>
         <p:nvSpPr>
-          <p:cNvPr id="20" name="text-19"/>
+          <p:cNvPr id="19" name="text-18"/>
           <p:cNvSpPr txBox="1"/>
           <p:nvPr/>
         </p:nvSpPr>
@@ -9798,7 +11703,7 @@
       </p:sp>
       <p:pic>
         <p:nvPicPr>
-          <p:cNvPr id="21" name="svg-20" descr="preencoded.png">    </p:cNvPr>
+          <p:cNvPr id="20" name="svg-19" descr="preencoded.png">    </p:cNvPr>
           <p:cNvPicPr>
             <a:picLocks noChangeAspect="1"/>
           </p:cNvPicPr>
@@ -9822,7 +11727,7 @@
       </p:pic>
       <p:sp>
         <p:nvSpPr>
-          <p:cNvPr id="22" name="text-21"/>
+          <p:cNvPr id="21" name="text-20"/>
           <p:cNvSpPr txBox="1"/>
           <p:nvPr/>
         </p:nvSpPr>
@@ -9856,7 +11761,7 @@
                 <a:ea typeface="Noto Serif Display Light" pitchFamily="34" charset="-122"/>
                 <a:cs typeface="Noto Serif Display Light" pitchFamily="34" charset="-120"/>
               </a:rPr>
-              <a:t>собрал всё в план</a:t>
+              <a:t>а для вузов США важно, что ты отправляешь</a:t>
             </a:r>
             <a:endParaRPr lang="en-US" sz="1800" dirty="0"/>
           </a:p>

</xml_diff>